<commit_message>
Add NJ tree + cut-off; update report and slides to the cut-off conclusion
</commit_message>
<xml_diff>
--- a/presentation/BarcodeID_slides.pptx
+++ b/presentation/BarcodeID_slides.pptx
@@ -18,6 +18,7 @@
     <p:sldId id="266" r:id="rId18"/>
     <p:sldId id="267" r:id="rId19"/>
     <p:sldId id="268" r:id="rId20"/>
+    <p:sldId id="269" r:id="rId21"/>
   </p:sldIdLst>
   <p:sldSz cx="12191695" cy="6858000" type="screen4x3"/>
   <p:notesSz cx="6858000" cy="9144000"/>
@@ -584,7 +585,7 @@
           <a:lstStyle/>
           <a:p>
             <a:r>
-              <a:t>Is it machine learning that makes k-NN safe? We tested the classic best-close-match rule with the same kind of cut-off: it also flagged 100% of unknown species. So the safety comes from having a calibrated distance cut-off. What k-NN adds is that it loses fewer known species at the same safety: 88% correct versus 77%.</a:t>
+              <a:t>A fair question: the classifiers had an 'unknown' cut-off, the tree did not. So we gave the same tree one: if a query is far, along the tree, from every reference sequence, it says 'unknown'. The cut-off is calibrated on training sequences only, like the others. Result: the tree became as safe as k-NN. Across all 39 species it wrongly named 10%, k-NN 14%, plain tree 67%. The curves show every possible cut-off: the pink tree curve and the orange k-NN curve almost overlap.</a:t>
             </a:r>
           </a:p>
         </p:txBody>
@@ -654,7 +655,7 @@
           <a:lstStyle/>
           <a:p>
             <a:r>
-              <a:t>Speed, measured on the same laptop for the same 236 queries: the tree pipeline takes 868 ms per query, k-NN 3.3 ms, about 264 times faster. The tree has no training, but it must be rebuilt with all reference barcodes whenever new queries arrive, and that cost grows steeply with the database. Training a classifier takes about one second.</a:t>
+              <a:t>Three independent results say the same thing. A plain distance rule, best close match, becomes just as safe when calibrated like k-NN. The tree becomes just as safe with a cut-off. And the threshold curves overlap. So safety comes from the calibrated cut-off, not from machine learning. What machine learning adds: speed, and slightly fewer losses on known species at its calibration (88% correct versus 85% for the tree + cut-off and 77% for best close match, Condition B main run).</a:t>
             </a:r>
           </a:p>
         </p:txBody>
@@ -724,7 +725,7 @@
           <a:lstStyle/>
           <a:p>
             <a:r>
-              <a:t>Be honest about the limits. One group, one gene, one region. A small dataset. Barcode sharing that no barcode-only method can solve. And the comparison is not perfectly like-for-like: we gave the tree no extra 'unknown' threshold, on purpose, to test the method as usually applied. A distance threshold on the tree could make it safer.</a:t>
+              <a:t>Speed, measured on the same laptop for the same 236 queries: the tree pipeline takes 868 ms per query, k-NN 3.3 ms, about 264 times faster. The tree has no training, but it must be rebuilt with all reference barcodes whenever new queries arrive, and that cost grows steeply with the database. Training a classifier takes about one second.</a:t>
             </a:r>
           </a:p>
         </p:txBody>
@@ -794,7 +795,77 @@
           <a:lstStyle/>
           <a:p>
             <a:r>
-              <a:t>Our one-sentence answer, and the practical advice: for identification, use a distance-aware method with a calibrated 'unknown' threshold, such as k-NN, rather than reading a species name off a tree; report barcode-sharing groups at genus level. Then invite questions.</a:t>
+              <a:t>Be honest about the limits. One group, one gene, one region. A small dataset. Barcode sharing that no barcode-only method can solve. And the tree's cut-off was calibrated inside the tree, while the classifiers used cross-validation, so the two cut-offs sit at slightly different points of the trade-off.</a:t>
+            </a:r>
+          </a:p>
+        </p:txBody>
+      </p:sp>
+      <p:sp>
+        <p:nvSpPr>
+          <p:cNvPr id="4" name="Slide Number Placeholder 3"/>
+          <p:cNvSpPr>
+            <a:spLocks noGrp="1"/>
+          </p:cNvSpPr>
+          <p:nvPr>
+            <p:ph type="sldNum" idx="5" sz="quarter"/>
+          </p:nvPr>
+        </p:nvSpPr>
+        <p:spPr/>
+      </p:sp>
+    </p:spTree>
+  </p:cSld>
+  <p:clrMapOvr>
+    <a:masterClrMapping/>
+  </p:clrMapOvr>
+</p:notes>
+</file>
+
+<file path=ppt/notesSlides/notesSlide14.xml><?xml version="1.0" encoding="utf-8"?>
+<p:notes xmlns:a="http://schemas.openxmlformats.org/drawingml/2006/main" xmlns:p="http://schemas.openxmlformats.org/presentationml/2006/main" xmlns:r="http://schemas.openxmlformats.org/officeDocument/2006/relationships">
+  <p:cSld>
+    <p:spTree>
+      <p:nvGrpSpPr>
+        <p:cNvPr id="1" name=""/>
+        <p:cNvGrpSpPr/>
+        <p:nvPr/>
+      </p:nvGrpSpPr>
+      <p:grpSpPr>
+        <a:xfrm>
+          <a:off x="0" y="0"/>
+          <a:ext cx="0" cy="0"/>
+          <a:chOff x="0" y="0"/>
+          <a:chExt cx="0" cy="0"/>
+        </a:xfrm>
+      </p:grpSpPr>
+      <p:sp>
+        <p:nvSpPr>
+          <p:cNvPr id="2" name="Slide Image Placeholder 1"/>
+          <p:cNvSpPr>
+            <a:spLocks noGrp="1"/>
+          </p:cNvSpPr>
+          <p:nvPr>
+            <p:ph type="sldImg" idx="2"/>
+          </p:nvPr>
+        </p:nvSpPr>
+        <p:spPr/>
+      </p:sp>
+      <p:sp>
+        <p:nvSpPr>
+          <p:cNvPr id="3" name="Notes Placeholder 2"/>
+          <p:cNvSpPr>
+            <a:spLocks noGrp="1"/>
+          </p:cNvSpPr>
+          <p:nvPr>
+            <p:ph type="body" idx="3" sz="quarter"/>
+          </p:nvPr>
+        </p:nvSpPr>
+        <p:spPr/>
+        <p:txBody>
+          <a:bodyPr/>
+          <a:lstStyle/>
+          <a:p>
+            <a:r>
+              <a:t>Our one-sentence answer: it is the calibrated 'unknown' cut-off that makes identification safe, not the choice between a tree and machine learning. The practical advice: whatever method you use, give it a calibrated cut-off; k-NN is the fast way to do it; report barcode-sharing groups at genus level. Then invite questions.</a:t>
             </a:r>
           </a:p>
         </p:txBody>
@@ -1214,7 +1285,7 @@
           <a:lstStyle/>
           <a:p>
             <a:r>
-              <a:t>Now the species is missing from the database. Read the colours: green is safe, yellow a wrong species in the right genus, red a wrong genus. The NJ tree named a wrong species for 67% of unknown queries. Without a threshold the classifiers always name a known species, and random forest even picks the wrong genus. With the calibrated threshold, k-NN flagged every unknown query and still gave the correct genus.</a:t>
+              <a:t>Now the species is missing from the database. Read the colours: green is safe, yellow a wrong species in the right genus, red a wrong genus. The plain NJ tree named a wrong species for 67% of unknown queries. Without a threshold the classifiers always name a known species, and random forest even picks the wrong genus. With a calibrated cut-off, k-NN flagged every unknown query and still gave the correct genus, and so did the same NJ tree once it got a cut-off: the bottom row.</a:t>
             </a:r>
           </a:p>
         </p:txBody>
@@ -1284,7 +1355,7 @@
           <a:lstStyle/>
           <a:p>
             <a:r>
-              <a:t>Is that just a lucky choice of 8 species? We removed every one of the 39 eligible species on its own. Averaged over species, the tree wrongly named the missing species 67% of the time, k-NN 14%. For the 29 species that do not share their barcode, k-NN never named a wrong species, not for a single query, and still gave the correct genus 99% of the time. The tree even put two species into the wrong genus.</a:t>
+              <a:t>Is that just a lucky choice of 8 species? We removed every one of the 39 eligible species on its own. Averaged over species, the plain tree wrongly named the missing species 67% of the time. With a cut-off, the same tree wrongly named 10% and k-NN 14%. For the 29 species that do not share their barcode, both never named a wrong species. The plain tree even put two species into the wrong genus.</a:t>
             </a:r>
           </a:p>
         </p:txBody>
@@ -4639,57 +4710,35 @@
                 </a:solidFill>
                 <a:latin typeface="Cambria"/>
               </a:rPr>
-              <a:t>Where does the safety come from?</a:t>
-            </a:r>
-          </a:p>
-        </p:txBody>
-      </p:sp>
-      <p:sp>
-        <p:nvSpPr>
-          <p:cNvPr id="4" name="Rounded Rectangle 3"/>
-          <p:cNvSpPr/>
-          <p:nvPr/>
-        </p:nvSpPr>
-        <p:spPr>
-          <a:xfrm>
-            <a:off x="548640" y="1463040"/>
-            <a:ext cx="3566160" cy="4206240"/>
-          </a:xfrm>
-          <a:prstGeom prst="roundRect">
-            <a:avLst>
-              <a:gd name="adj" fmla="val 8000"/>
-            </a:avLst>
-          </a:prstGeom>
-          <a:solidFill>
-            <a:srgbClr val="E6F0EF"/>
-          </a:solidFill>
-          <a:ln>
-            <a:noFill/>
-          </a:ln>
-          <a:effectLst/>
-        </p:spPr>
-        <p:style>
-          <a:lnRef idx="1">
-            <a:schemeClr val="accent1"/>
-          </a:lnRef>
-          <a:fillRef idx="3">
-            <a:schemeClr val="accent1"/>
-          </a:fillRef>
-          <a:effectRef idx="2">
-            <a:schemeClr val="accent1"/>
-          </a:effectRef>
-          <a:fontRef idx="minor">
-            <a:schemeClr val="lt1"/>
-          </a:fontRef>
-        </p:style>
-        <p:txBody>
-          <a:bodyPr rtlCol="0" anchor="ctr"/>
-          <a:lstStyle/>
-          <a:p>
-            <a:pPr algn="ctr"/>
-          </a:p>
-        </p:txBody>
-      </p:sp>
+              <a:t>A fair test: give the tree a cut-off</a:t>
+            </a:r>
+          </a:p>
+        </p:txBody>
+      </p:sp>
+      <p:pic>
+        <p:nvPicPr>
+          <p:cNvPr id="4" name="Picture 3" descr="threshold_curve.png"/>
+          <p:cNvPicPr>
+            <a:picLocks noChangeAspect="1"/>
+          </p:cNvPicPr>
+          <p:nvPr/>
+        </p:nvPicPr>
+        <p:blipFill>
+          <a:blip r:embed="rId3"/>
+          <a:stretch>
+            <a:fillRect/>
+          </a:stretch>
+        </p:blipFill>
+        <p:spPr>
+          <a:xfrm>
+            <a:off x="457200" y="1325880"/>
+            <a:ext cx="6766560" cy="4446596"/>
+          </a:xfrm>
+          <a:prstGeom prst="rect">
+            <a:avLst/>
+          </a:prstGeom>
+        </p:spPr>
+      </p:pic>
       <p:sp>
         <p:nvSpPr>
           <p:cNvPr id="5" name="TextBox 4"/>
@@ -4698,8 +4747,8 @@
         </p:nvSpPr>
         <p:spPr>
           <a:xfrm>
-            <a:off x="868680" y="1691640"/>
-            <a:ext cx="3017520" cy="457200"/>
+            <a:off x="7680960" y="1463040"/>
+            <a:ext cx="4206240" cy="868680"/>
           </a:xfrm>
           <a:prstGeom prst="rect">
             <a:avLst/>
@@ -4714,17 +4763,17 @@
           <a:p>
             <a:pPr algn="l">
               <a:spcAft>
-                <a:spcPts val="990"/>
-              </a:spcAft>
-            </a:pPr>
-            <a:r>
-              <a:rPr sz="2200" b="1" i="0">
-                <a:solidFill>
-                  <a:srgbClr val="0F3B40"/>
-                </a:solidFill>
-                <a:latin typeface="Calibri"/>
-              </a:rPr>
-              <a:t>Best close match</a:t>
+                <a:spcPts val="1980"/>
+              </a:spcAft>
+            </a:pPr>
+            <a:r>
+              <a:rPr sz="4400" b="1" i="0">
+                <a:solidFill>
+                  <a:srgbClr val="0C8A0C"/>
+                </a:solidFill>
+                <a:latin typeface="Cambria"/>
+              </a:rPr>
+              <a:t>67% → 10%</a:t>
             </a:r>
           </a:p>
         </p:txBody>
@@ -4737,8 +4786,8 @@
         </p:nvSpPr>
         <p:spPr>
           <a:xfrm>
-            <a:off x="868680" y="2194560"/>
-            <a:ext cx="3017520" cy="365760"/>
+            <a:off x="7680960" y="2331720"/>
+            <a:ext cx="4206240" cy="731520"/>
           </a:xfrm>
           <a:prstGeom prst="rect">
             <a:avLst/>
@@ -4757,13 +4806,14 @@
               </a:spcAft>
             </a:pPr>
             <a:r>
-              <a:rPr sz="1400" b="0" i="1">
+              <a:rPr sz="1400" b="0" i="0">
                 <a:solidFill>
                   <a:srgbClr val="5A5A55"/>
                 </a:solidFill>
                 <a:latin typeface="Calibri"/>
               </a:rPr>
-              <a:t>same cut-off as k-NN</a:t>
+              <a:t>missing species wrongly named:
+plain tree → tree + cut-off</a:t>
             </a:r>
           </a:p>
         </p:txBody>
@@ -4776,8 +4826,8 @@
         </p:nvSpPr>
         <p:spPr>
           <a:xfrm>
-            <a:off x="868680" y="2697480"/>
-            <a:ext cx="3017520" cy="868680"/>
+            <a:off x="7680960" y="3246120"/>
+            <a:ext cx="4114800" cy="2743200"/>
           </a:xfrm>
           <a:prstGeom prst="rect">
             <a:avLst/>
@@ -4792,503 +4842,76 @@
           <a:p>
             <a:pPr algn="l">
               <a:spcAft>
-                <a:spcPts val="2070"/>
-              </a:spcAft>
-            </a:pPr>
-            <a:r>
-              <a:rPr sz="4600" b="1" i="0">
-                <a:solidFill>
-                  <a:srgbClr val="0C8A0C"/>
-                </a:solidFill>
-                <a:latin typeface="Cambria"/>
-              </a:rPr>
-              <a:t>100%</a:t>
-            </a:r>
-          </a:p>
-        </p:txBody>
-      </p:sp>
-      <p:sp>
-        <p:nvSpPr>
-          <p:cNvPr id="8" name="TextBox 7"/>
-          <p:cNvSpPr txBox="1"/>
-          <p:nvPr/>
-        </p:nvSpPr>
-        <p:spPr>
-          <a:xfrm>
-            <a:off x="868680" y="3566160"/>
-            <a:ext cx="3017520" cy="731520"/>
-          </a:xfrm>
-          <a:prstGeom prst="rect">
-            <a:avLst/>
-          </a:prstGeom>
-          <a:noFill/>
-        </p:spPr>
-        <p:txBody>
-          <a:bodyPr wrap="square" anchor="t" lIns="0" rIns="0" tIns="0" bIns="0">
-            <a:spAutoFit/>
-          </a:bodyPr>
-          <a:lstStyle/>
+                <a:spcPts val="720"/>
+              </a:spcAft>
+            </a:pPr>
+            <a:r>
+              <a:rPr sz="1600" b="1" i="0">
+                <a:solidFill>
+                  <a:srgbClr val="0F3B40"/>
+                </a:solidFill>
+                <a:latin typeface="Calibri"/>
+              </a:rPr>
+              <a:t>k-NN: </a:t>
+            </a:r>
+            <a:r>
+              <a:rPr sz="1600" b="0" i="0">
+                <a:solidFill>
+                  <a:srgbClr val="1A1A1A"/>
+                </a:solidFill>
+                <a:latin typeface="Calibri"/>
+              </a:rPr>
+              <a:t>14% with its cut-off (39 species).</a:t>
+            </a:r>
+          </a:p>
           <a:p>
             <a:pPr algn="l">
               <a:spcAft>
-                <a:spcPts val="630"/>
-              </a:spcAft>
-            </a:pPr>
-            <a:r>
-              <a:rPr sz="1400" b="0" i="0">
-                <a:solidFill>
-                  <a:srgbClr val="5A5A55"/>
+                <a:spcPts val="720"/>
+              </a:spcAft>
+            </a:pPr>
+            <a:r>
+              <a:rPr sz="1600" b="1" i="0">
+                <a:solidFill>
+                  <a:srgbClr val="0F3B40"/>
                 </a:solidFill>
                 <a:latin typeface="Calibri"/>
               </a:rPr>
-              <a:t>unknown species flagged</a:t>
-            </a:r>
-          </a:p>
-        </p:txBody>
-      </p:sp>
-      <p:sp>
-        <p:nvSpPr>
-          <p:cNvPr id="9" name="TextBox 8"/>
-          <p:cNvSpPr txBox="1"/>
-          <p:nvPr/>
-        </p:nvSpPr>
-        <p:spPr>
-          <a:xfrm>
-            <a:off x="868680" y="4160520"/>
-            <a:ext cx="3017520" cy="868680"/>
-          </a:xfrm>
-          <a:prstGeom prst="rect">
-            <a:avLst/>
-          </a:prstGeom>
-          <a:noFill/>
-        </p:spPr>
-        <p:txBody>
-          <a:bodyPr wrap="square" anchor="t" lIns="0" rIns="0" tIns="0" bIns="0">
-            <a:spAutoFit/>
-          </a:bodyPr>
-          <a:lstStyle/>
+              <a:t>Same balance: </a:t>
+            </a:r>
+            <a:r>
+              <a:rPr sz="1600" b="0" i="0">
+                <a:solidFill>
+                  <a:srgbClr val="1A1A1A"/>
+                </a:solidFill>
+                <a:latin typeface="Calibri"/>
+              </a:rPr>
+              <a:t>the curves of the tree + cut-off and k-NN almost overlap.</a:t>
+            </a:r>
+          </a:p>
           <a:p>
             <a:pPr algn="l">
               <a:spcAft>
-                <a:spcPts val="2070"/>
-              </a:spcAft>
-            </a:pPr>
-            <a:r>
-              <a:rPr sz="4600" b="1" i="0">
+                <a:spcPts val="720"/>
+              </a:spcAft>
+            </a:pPr>
+            <a:r>
+              <a:rPr sz="1600" b="1" i="0">
                 <a:solidFill>
                   <a:srgbClr val="0F3B40"/>
                 </a:solidFill>
-                <a:latin typeface="Cambria"/>
-              </a:rPr>
-              <a:t>77%</a:t>
-            </a:r>
-          </a:p>
-        </p:txBody>
-      </p:sp>
-      <p:sp>
-        <p:nvSpPr>
-          <p:cNvPr id="10" name="TextBox 9"/>
-          <p:cNvSpPr txBox="1"/>
-          <p:nvPr/>
-        </p:nvSpPr>
-        <p:spPr>
-          <a:xfrm>
-            <a:off x="868680" y="5029200"/>
-            <a:ext cx="3017520" cy="731520"/>
-          </a:xfrm>
-          <a:prstGeom prst="rect">
-            <a:avLst/>
-          </a:prstGeom>
-          <a:noFill/>
-        </p:spPr>
-        <p:txBody>
-          <a:bodyPr wrap="square" anchor="t" lIns="0" rIns="0" tIns="0" bIns="0">
-            <a:spAutoFit/>
-          </a:bodyPr>
-          <a:lstStyle/>
-          <a:p>
-            <a:pPr algn="l">
-              <a:spcAft>
-                <a:spcPts val="630"/>
-              </a:spcAft>
-            </a:pPr>
-            <a:r>
-              <a:rPr sz="1400" b="0" i="0">
-                <a:solidFill>
-                  <a:srgbClr val="5A5A55"/>
-                </a:solidFill>
                 <a:latin typeface="Calibri"/>
               </a:rPr>
-              <a:t>known species still correct</a:t>
-            </a:r>
-          </a:p>
-        </p:txBody>
-      </p:sp>
-      <p:sp>
-        <p:nvSpPr>
-          <p:cNvPr id="11" name="Rounded Rectangle 10"/>
-          <p:cNvSpPr/>
-          <p:nvPr/>
-        </p:nvSpPr>
-        <p:spPr>
-          <a:xfrm>
-            <a:off x="4480559" y="1463040"/>
-            <a:ext cx="3566160" cy="4206240"/>
-          </a:xfrm>
-          <a:prstGeom prst="roundRect">
-            <a:avLst>
-              <a:gd name="adj" fmla="val 8000"/>
-            </a:avLst>
-          </a:prstGeom>
-          <a:solidFill>
-            <a:srgbClr val="FBF1DC"/>
-          </a:solidFill>
-          <a:ln>
-            <a:noFill/>
-          </a:ln>
-          <a:effectLst/>
-        </p:spPr>
-        <p:style>
-          <a:lnRef idx="1">
-            <a:schemeClr val="accent1"/>
-          </a:lnRef>
-          <a:fillRef idx="3">
-            <a:schemeClr val="accent1"/>
-          </a:fillRef>
-          <a:effectRef idx="2">
-            <a:schemeClr val="accent1"/>
-          </a:effectRef>
-          <a:fontRef idx="minor">
-            <a:schemeClr val="lt1"/>
-          </a:fontRef>
-        </p:style>
-        <p:txBody>
-          <a:bodyPr rtlCol="0" anchor="ctr"/>
-          <a:lstStyle/>
-          <a:p>
-            <a:pPr algn="ctr"/>
-          </a:p>
-        </p:txBody>
-      </p:sp>
-      <p:sp>
-        <p:nvSpPr>
-          <p:cNvPr id="12" name="TextBox 11"/>
-          <p:cNvSpPr txBox="1"/>
-          <p:nvPr/>
-        </p:nvSpPr>
-        <p:spPr>
-          <a:xfrm>
-            <a:off x="4800599" y="1691640"/>
-            <a:ext cx="3017520" cy="457200"/>
-          </a:xfrm>
-          <a:prstGeom prst="rect">
-            <a:avLst/>
-          </a:prstGeom>
-          <a:noFill/>
-        </p:spPr>
-        <p:txBody>
-          <a:bodyPr wrap="square" anchor="t" lIns="0" rIns="0" tIns="0" bIns="0">
-            <a:spAutoFit/>
-          </a:bodyPr>
-          <a:lstStyle/>
-          <a:p>
-            <a:pPr algn="l">
-              <a:spcAft>
-                <a:spcPts val="990"/>
-              </a:spcAft>
-            </a:pPr>
-            <a:r>
-              <a:rPr sz="2200" b="1" i="0">
-                <a:solidFill>
-                  <a:srgbClr val="0F3B40"/>
+              <a:t>The cut-off </a:t>
+            </a:r>
+            <a:r>
+              <a:rPr sz="1600" b="0" i="0">
+                <a:solidFill>
+                  <a:srgbClr val="1A1A1A"/>
                 </a:solidFill>
                 <a:latin typeface="Calibri"/>
               </a:rPr>
-              <a:t>k-NN</a:t>
-            </a:r>
-          </a:p>
-        </p:txBody>
-      </p:sp>
-      <p:sp>
-        <p:nvSpPr>
-          <p:cNvPr id="13" name="TextBox 12"/>
-          <p:cNvSpPr txBox="1"/>
-          <p:nvPr/>
-        </p:nvSpPr>
-        <p:spPr>
-          <a:xfrm>
-            <a:off x="4800599" y="2194560"/>
-            <a:ext cx="3017520" cy="365760"/>
-          </a:xfrm>
-          <a:prstGeom prst="rect">
-            <a:avLst/>
-          </a:prstGeom>
-          <a:noFill/>
-        </p:spPr>
-        <p:txBody>
-          <a:bodyPr wrap="square" anchor="t" lIns="0" rIns="0" tIns="0" bIns="0">
-            <a:spAutoFit/>
-          </a:bodyPr>
-          <a:lstStyle/>
-          <a:p>
-            <a:pPr algn="l">
-              <a:spcAft>
-                <a:spcPts val="630"/>
-              </a:spcAft>
-            </a:pPr>
-            <a:r>
-              <a:rPr sz="1400" b="0" i="1">
-                <a:solidFill>
-                  <a:srgbClr val="5A5A55"/>
-                </a:solidFill>
-                <a:latin typeface="Calibri"/>
-              </a:rPr>
-              <a:t>calibrated cut-off</a:t>
-            </a:r>
-          </a:p>
-        </p:txBody>
-      </p:sp>
-      <p:sp>
-        <p:nvSpPr>
-          <p:cNvPr id="14" name="TextBox 13"/>
-          <p:cNvSpPr txBox="1"/>
-          <p:nvPr/>
-        </p:nvSpPr>
-        <p:spPr>
-          <a:xfrm>
-            <a:off x="4800599" y="2697480"/>
-            <a:ext cx="3017520" cy="868680"/>
-          </a:xfrm>
-          <a:prstGeom prst="rect">
-            <a:avLst/>
-          </a:prstGeom>
-          <a:noFill/>
-        </p:spPr>
-        <p:txBody>
-          <a:bodyPr wrap="square" anchor="t" lIns="0" rIns="0" tIns="0" bIns="0">
-            <a:spAutoFit/>
-          </a:bodyPr>
-          <a:lstStyle/>
-          <a:p>
-            <a:pPr algn="l">
-              <a:spcAft>
-                <a:spcPts val="2070"/>
-              </a:spcAft>
-            </a:pPr>
-            <a:r>
-              <a:rPr sz="4600" b="1" i="0">
-                <a:solidFill>
-                  <a:srgbClr val="0C8A0C"/>
-                </a:solidFill>
-                <a:latin typeface="Cambria"/>
-              </a:rPr>
-              <a:t>100%</a:t>
-            </a:r>
-          </a:p>
-        </p:txBody>
-      </p:sp>
-      <p:sp>
-        <p:nvSpPr>
-          <p:cNvPr id="15" name="TextBox 14"/>
-          <p:cNvSpPr txBox="1"/>
-          <p:nvPr/>
-        </p:nvSpPr>
-        <p:spPr>
-          <a:xfrm>
-            <a:off x="4800599" y="3566160"/>
-            <a:ext cx="3017520" cy="731520"/>
-          </a:xfrm>
-          <a:prstGeom prst="rect">
-            <a:avLst/>
-          </a:prstGeom>
-          <a:noFill/>
-        </p:spPr>
-        <p:txBody>
-          <a:bodyPr wrap="square" anchor="t" lIns="0" rIns="0" tIns="0" bIns="0">
-            <a:spAutoFit/>
-          </a:bodyPr>
-          <a:lstStyle/>
-          <a:p>
-            <a:pPr algn="l">
-              <a:spcAft>
-                <a:spcPts val="630"/>
-              </a:spcAft>
-            </a:pPr>
-            <a:r>
-              <a:rPr sz="1400" b="0" i="0">
-                <a:solidFill>
-                  <a:srgbClr val="5A5A55"/>
-                </a:solidFill>
-                <a:latin typeface="Calibri"/>
-              </a:rPr>
-              <a:t>unknown species flagged</a:t>
-            </a:r>
-          </a:p>
-        </p:txBody>
-      </p:sp>
-      <p:sp>
-        <p:nvSpPr>
-          <p:cNvPr id="16" name="TextBox 15"/>
-          <p:cNvSpPr txBox="1"/>
-          <p:nvPr/>
-        </p:nvSpPr>
-        <p:spPr>
-          <a:xfrm>
-            <a:off x="4800599" y="4160520"/>
-            <a:ext cx="3017520" cy="868680"/>
-          </a:xfrm>
-          <a:prstGeom prst="rect">
-            <a:avLst/>
-          </a:prstGeom>
-          <a:noFill/>
-        </p:spPr>
-        <p:txBody>
-          <a:bodyPr wrap="square" anchor="t" lIns="0" rIns="0" tIns="0" bIns="0">
-            <a:spAutoFit/>
-          </a:bodyPr>
-          <a:lstStyle/>
-          <a:p>
-            <a:pPr algn="l">
-              <a:spcAft>
-                <a:spcPts val="2070"/>
-              </a:spcAft>
-            </a:pPr>
-            <a:r>
-              <a:rPr sz="4600" b="1" i="0">
-                <a:solidFill>
-                  <a:srgbClr val="0F3B40"/>
-                </a:solidFill>
-                <a:latin typeface="Cambria"/>
-              </a:rPr>
-              <a:t>88%</a:t>
-            </a:r>
-          </a:p>
-        </p:txBody>
-      </p:sp>
-      <p:sp>
-        <p:nvSpPr>
-          <p:cNvPr id="17" name="TextBox 16"/>
-          <p:cNvSpPr txBox="1"/>
-          <p:nvPr/>
-        </p:nvSpPr>
-        <p:spPr>
-          <a:xfrm>
-            <a:off x="4800599" y="5029200"/>
-            <a:ext cx="3017520" cy="731520"/>
-          </a:xfrm>
-          <a:prstGeom prst="rect">
-            <a:avLst/>
-          </a:prstGeom>
-          <a:noFill/>
-        </p:spPr>
-        <p:txBody>
-          <a:bodyPr wrap="square" anchor="t" lIns="0" rIns="0" tIns="0" bIns="0">
-            <a:spAutoFit/>
-          </a:bodyPr>
-          <a:lstStyle/>
-          <a:p>
-            <a:pPr algn="l">
-              <a:spcAft>
-                <a:spcPts val="630"/>
-              </a:spcAft>
-            </a:pPr>
-            <a:r>
-              <a:rPr sz="1400" b="0" i="0">
-                <a:solidFill>
-                  <a:srgbClr val="5A5A55"/>
-                </a:solidFill>
-                <a:latin typeface="Calibri"/>
-              </a:rPr>
-              <a:t>known species still correct</a:t>
-            </a:r>
-          </a:p>
-        </p:txBody>
-      </p:sp>
-      <p:sp>
-        <p:nvSpPr>
-          <p:cNvPr id="18" name="TextBox 17"/>
-          <p:cNvSpPr txBox="1"/>
-          <p:nvPr/>
-        </p:nvSpPr>
-        <p:spPr>
-          <a:xfrm>
-            <a:off x="8595360" y="1737360"/>
-            <a:ext cx="3200400" cy="4023360"/>
-          </a:xfrm>
-          <a:prstGeom prst="rect">
-            <a:avLst/>
-          </a:prstGeom>
-          <a:noFill/>
-        </p:spPr>
-        <p:txBody>
-          <a:bodyPr wrap="square" anchor="t" lIns="0" rIns="0" tIns="0" bIns="0">
-            <a:spAutoFit/>
-          </a:bodyPr>
-          <a:lstStyle/>
-          <a:p>
-            <a:pPr algn="l">
-              <a:spcAft>
-                <a:spcPts val="765"/>
-              </a:spcAft>
-            </a:pPr>
-            <a:r>
-              <a:rPr sz="1700" b="1" i="0">
-                <a:solidFill>
-                  <a:srgbClr val="0F3B40"/>
-                </a:solidFill>
-                <a:latin typeface="Calibri"/>
-              </a:rPr>
-              <a:t>The safety comes from the cut-off, </a:t>
-            </a:r>
-            <a:r>
-              <a:rPr sz="1700" b="0" i="0">
-                <a:solidFill>
-                  <a:srgbClr val="1A1A1A"/>
-                </a:solidFill>
-                <a:latin typeface="Calibri"/>
-              </a:rPr>
-              <a:t>not from machine learning itself.</a:t>
-            </a:r>
-          </a:p>
-          <a:p>
-            <a:pPr algn="l">
-              <a:spcAft>
-                <a:spcPts val="765"/>
-              </a:spcAft>
-            </a:pPr>
-            <a:r>
-              <a:rPr sz="1700" b="1" i="0">
-                <a:solidFill>
-                  <a:srgbClr val="0F3B40"/>
-                </a:solidFill>
-                <a:latin typeface="Calibri"/>
-              </a:rPr>
-              <a:t>What k-NN adds: </a:t>
-            </a:r>
-            <a:r>
-              <a:rPr sz="1700" b="0" i="0">
-                <a:solidFill>
-                  <a:srgbClr val="1A1A1A"/>
-                </a:solidFill>
-                <a:latin typeface="Calibri"/>
-              </a:rPr>
-              <a:t>far fewer losses on known species: its vote among five neighbours resolves near-ties that the plain distance rule calls 'ambiguous'.</a:t>
-            </a:r>
-          </a:p>
-          <a:p>
-            <a:pPr algn="l">
-              <a:spcAft>
-                <a:spcPts val="765"/>
-              </a:spcAft>
-            </a:pPr>
-            <a:r>
-              <a:rPr sz="1300" b="0" i="1">
-                <a:solidFill>
-                  <a:srgbClr val="5A5A55"/>
-                </a:solidFill>
-                <a:latin typeface="Calibri"/>
-              </a:rPr>
-              <a:t>Condition B, main run.</a:t>
+              <a:t>is calibrated on training sequences only, inside the same tree.</a:t>
             </a:r>
           </a:p>
         </p:txBody>
@@ -5392,45 +5015,120 @@
                 </a:solidFill>
                 <a:latin typeface="Cambria"/>
               </a:rPr>
-              <a:t>Speed: about 260 times faster</a:t>
-            </a:r>
-          </a:p>
-        </p:txBody>
-      </p:sp>
-      <p:pic>
-        <p:nvPicPr>
-          <p:cNvPr id="4" name="Picture 3" descr="runtime.png"/>
-          <p:cNvPicPr>
-            <a:picLocks noChangeAspect="1"/>
-          </p:cNvPicPr>
-          <p:nvPr/>
-        </p:nvPicPr>
-        <p:blipFill>
-          <a:blip r:embed="rId3"/>
-          <a:stretch>
-            <a:fillRect/>
-          </a:stretch>
-        </p:blipFill>
-        <p:spPr>
-          <a:xfrm>
-            <a:off x="457200" y="1371600"/>
-            <a:ext cx="7315200" cy="4598125"/>
-          </a:xfrm>
-          <a:prstGeom prst="rect">
-            <a:avLst/>
-          </a:prstGeom>
-        </p:spPr>
-      </p:pic>
-      <p:sp>
-        <p:nvSpPr>
-          <p:cNvPr id="5" name="TextBox 4"/>
+              <a:t>So where does the safety come from?</a:t>
+            </a:r>
+          </a:p>
+        </p:txBody>
+      </p:sp>
+      <p:sp>
+        <p:nvSpPr>
+          <p:cNvPr id="4" name="Rounded Rectangle 3"/>
+          <p:cNvSpPr/>
+          <p:nvPr/>
+        </p:nvSpPr>
+        <p:spPr>
+          <a:xfrm>
+            <a:off x="548640" y="1417320"/>
+            <a:ext cx="6949440" cy="1280160"/>
+          </a:xfrm>
+          <a:prstGeom prst="roundRect">
+            <a:avLst>
+              <a:gd name="adj" fmla="val 8000"/>
+            </a:avLst>
+          </a:prstGeom>
+          <a:solidFill>
+            <a:srgbClr val="E6F0EF"/>
+          </a:solidFill>
+          <a:ln>
+            <a:noFill/>
+          </a:ln>
+          <a:effectLst/>
+        </p:spPr>
+        <p:style>
+          <a:lnRef idx="1">
+            <a:schemeClr val="accent1"/>
+          </a:lnRef>
+          <a:fillRef idx="3">
+            <a:schemeClr val="accent1"/>
+          </a:fillRef>
+          <a:effectRef idx="2">
+            <a:schemeClr val="accent1"/>
+          </a:effectRef>
+          <a:fontRef idx="minor">
+            <a:schemeClr val="lt1"/>
+          </a:fontRef>
+        </p:style>
+        <p:txBody>
+          <a:bodyPr rtlCol="0" anchor="ctr"/>
+          <a:lstStyle/>
+          <a:p>
+            <a:pPr algn="ctr"/>
+          </a:p>
+        </p:txBody>
+      </p:sp>
+      <p:sp>
+        <p:nvSpPr>
+          <p:cNvPr id="5" name="Oval 4"/>
+          <p:cNvSpPr/>
+          <p:nvPr/>
+        </p:nvSpPr>
+        <p:spPr>
+          <a:xfrm>
+            <a:off x="822960" y="1764792"/>
+            <a:ext cx="566928" cy="566928"/>
+          </a:xfrm>
+          <a:prstGeom prst="ellipse">
+            <a:avLst/>
+          </a:prstGeom>
+          <a:solidFill>
+            <a:srgbClr val="0F3B40"/>
+          </a:solidFill>
+          <a:ln>
+            <a:noFill/>
+          </a:ln>
+          <a:effectLst/>
+        </p:spPr>
+        <p:style>
+          <a:lnRef idx="1">
+            <a:schemeClr val="accent1"/>
+          </a:lnRef>
+          <a:fillRef idx="3">
+            <a:schemeClr val="accent1"/>
+          </a:fillRef>
+          <a:effectRef idx="2">
+            <a:schemeClr val="accent1"/>
+          </a:effectRef>
+          <a:fontRef idx="minor">
+            <a:schemeClr val="lt1"/>
+          </a:fontRef>
+        </p:style>
+        <p:txBody>
+          <a:bodyPr rtlCol="0" anchor="ctr" lIns="0" rIns="0" tIns="0" bIns="0"/>
+          <a:lstStyle/>
+          <a:p>
+            <a:pPr algn="ctr"/>
+            <a:r>
+              <a:rPr sz="1800" b="1">
+                <a:solidFill>
+                  <a:srgbClr val="FFFFFF"/>
+                </a:solidFill>
+                <a:latin typeface="Cambria"/>
+              </a:rPr>
+              <a:t>1</a:t>
+            </a:r>
+          </a:p>
+        </p:txBody>
+      </p:sp>
+      <p:sp>
+        <p:nvSpPr>
+          <p:cNvPr id="6" name="TextBox 5"/>
           <p:cNvSpPr txBox="1"/>
           <p:nvPr/>
         </p:nvSpPr>
         <p:spPr>
           <a:xfrm>
-            <a:off x="8229600" y="1554480"/>
-            <a:ext cx="3566160" cy="868680"/>
+            <a:off x="1645920" y="1618488"/>
+            <a:ext cx="5669280" cy="457200"/>
           </a:xfrm>
           <a:prstGeom prst="rect">
             <a:avLst/>
@@ -5445,31 +5143,31 @@
           <a:p>
             <a:pPr algn="l">
               <a:spcAft>
-                <a:spcPts val="2700"/>
-              </a:spcAft>
-            </a:pPr>
-            <a:r>
-              <a:rPr sz="6000" b="1" i="0">
-                <a:solidFill>
-                  <a:srgbClr val="E09F1F"/>
-                </a:solidFill>
-                <a:latin typeface="Cambria"/>
-              </a:rPr>
-              <a:t>264×</a:t>
-            </a:r>
-          </a:p>
-        </p:txBody>
-      </p:sp>
-      <p:sp>
-        <p:nvSpPr>
-          <p:cNvPr id="6" name="TextBox 5"/>
+                <a:spcPts val="855"/>
+              </a:spcAft>
+            </a:pPr>
+            <a:r>
+              <a:rPr sz="1900" b="1" i="0">
+                <a:solidFill>
+                  <a:srgbClr val="0F3B40"/>
+                </a:solidFill>
+                <a:latin typeface="Calibri"/>
+              </a:rPr>
+              <a:t>Plain distance rule</a:t>
+            </a:r>
+          </a:p>
+        </p:txBody>
+      </p:sp>
+      <p:sp>
+        <p:nvSpPr>
+          <p:cNvPr id="7" name="TextBox 6"/>
           <p:cNvSpPr txBox="1"/>
           <p:nvPr/>
         </p:nvSpPr>
         <p:spPr>
           <a:xfrm>
-            <a:off x="8229600" y="2423160"/>
-            <a:ext cx="3566160" cy="731520"/>
+            <a:off x="1645920" y="2075688"/>
+            <a:ext cx="5669280" cy="548640"/>
           </a:xfrm>
           <a:prstGeom prst="rect">
             <a:avLst/>
@@ -5484,32 +5182,130 @@
           <a:p>
             <a:pPr algn="l">
               <a:spcAft>
-                <a:spcPts val="630"/>
-              </a:spcAft>
-            </a:pPr>
-            <a:r>
-              <a:rPr sz="1400" b="0" i="0">
-                <a:solidFill>
-                  <a:srgbClr val="5A5A55"/>
+                <a:spcPts val="675"/>
+              </a:spcAft>
+            </a:pPr>
+            <a:r>
+              <a:rPr sz="1500" b="0" i="0">
+                <a:solidFill>
+                  <a:srgbClr val="1A1A1A"/>
                 </a:solidFill>
                 <a:latin typeface="Calibri"/>
               </a:rPr>
-              <a:t>faster per query:
-k-NN vs the NJ tree</a:t>
-            </a:r>
-          </a:p>
-        </p:txBody>
-      </p:sp>
-      <p:sp>
-        <p:nvSpPr>
-          <p:cNvPr id="7" name="TextBox 6"/>
+              <a:t>Best close match, calibrated like k-NN: 100% of unknown species flagged.</a:t>
+            </a:r>
+          </a:p>
+        </p:txBody>
+      </p:sp>
+      <p:sp>
+        <p:nvSpPr>
+          <p:cNvPr id="8" name="Rounded Rectangle 7"/>
+          <p:cNvSpPr/>
+          <p:nvPr/>
+        </p:nvSpPr>
+        <p:spPr>
+          <a:xfrm>
+            <a:off x="548640" y="2880360"/>
+            <a:ext cx="6949440" cy="1280160"/>
+          </a:xfrm>
+          <a:prstGeom prst="roundRect">
+            <a:avLst>
+              <a:gd name="adj" fmla="val 8000"/>
+            </a:avLst>
+          </a:prstGeom>
+          <a:solidFill>
+            <a:srgbClr val="E6F0EF"/>
+          </a:solidFill>
+          <a:ln>
+            <a:noFill/>
+          </a:ln>
+          <a:effectLst/>
+        </p:spPr>
+        <p:style>
+          <a:lnRef idx="1">
+            <a:schemeClr val="accent1"/>
+          </a:lnRef>
+          <a:fillRef idx="3">
+            <a:schemeClr val="accent1"/>
+          </a:fillRef>
+          <a:effectRef idx="2">
+            <a:schemeClr val="accent1"/>
+          </a:effectRef>
+          <a:fontRef idx="minor">
+            <a:schemeClr val="lt1"/>
+          </a:fontRef>
+        </p:style>
+        <p:txBody>
+          <a:bodyPr rtlCol="0" anchor="ctr"/>
+          <a:lstStyle/>
+          <a:p>
+            <a:pPr algn="ctr"/>
+          </a:p>
+        </p:txBody>
+      </p:sp>
+      <p:sp>
+        <p:nvSpPr>
+          <p:cNvPr id="9" name="Oval 8"/>
+          <p:cNvSpPr/>
+          <p:nvPr/>
+        </p:nvSpPr>
+        <p:spPr>
+          <a:xfrm>
+            <a:off x="822960" y="3227832"/>
+            <a:ext cx="566928" cy="566928"/>
+          </a:xfrm>
+          <a:prstGeom prst="ellipse">
+            <a:avLst/>
+          </a:prstGeom>
+          <a:solidFill>
+            <a:srgbClr val="0F3B40"/>
+          </a:solidFill>
+          <a:ln>
+            <a:noFill/>
+          </a:ln>
+          <a:effectLst/>
+        </p:spPr>
+        <p:style>
+          <a:lnRef idx="1">
+            <a:schemeClr val="accent1"/>
+          </a:lnRef>
+          <a:fillRef idx="3">
+            <a:schemeClr val="accent1"/>
+          </a:fillRef>
+          <a:effectRef idx="2">
+            <a:schemeClr val="accent1"/>
+          </a:effectRef>
+          <a:fontRef idx="minor">
+            <a:schemeClr val="lt1"/>
+          </a:fontRef>
+        </p:style>
+        <p:txBody>
+          <a:bodyPr rtlCol="0" anchor="ctr" lIns="0" rIns="0" tIns="0" bIns="0"/>
+          <a:lstStyle/>
+          <a:p>
+            <a:pPr algn="ctr"/>
+            <a:r>
+              <a:rPr sz="1800" b="1">
+                <a:solidFill>
+                  <a:srgbClr val="FFFFFF"/>
+                </a:solidFill>
+                <a:latin typeface="Cambria"/>
+              </a:rPr>
+              <a:t>2</a:t>
+            </a:r>
+          </a:p>
+        </p:txBody>
+      </p:sp>
+      <p:sp>
+        <p:nvSpPr>
+          <p:cNvPr id="10" name="TextBox 9"/>
           <p:cNvSpPr txBox="1"/>
           <p:nvPr/>
         </p:nvSpPr>
         <p:spPr>
           <a:xfrm>
-            <a:off x="8229600" y="3429000"/>
-            <a:ext cx="3566160" cy="2377440"/>
+            <a:off x="1645920" y="3081528"/>
+            <a:ext cx="5669280" cy="457200"/>
           </a:xfrm>
           <a:prstGeom prst="rect">
             <a:avLst/>
@@ -5524,33 +5320,368 @@
           <a:p>
             <a:pPr algn="l">
               <a:spcAft>
-                <a:spcPts val="720"/>
-              </a:spcAft>
-            </a:pPr>
-            <a:r>
-              <a:rPr sz="1600" b="0" i="0">
+                <a:spcPts val="855"/>
+              </a:spcAft>
+            </a:pPr>
+            <a:r>
+              <a:rPr sz="1900" b="1" i="0">
+                <a:solidFill>
+                  <a:srgbClr val="0F3B40"/>
+                </a:solidFill>
+                <a:latin typeface="Calibri"/>
+              </a:rPr>
+              <a:t>The same tree + cut-off</a:t>
+            </a:r>
+          </a:p>
+        </p:txBody>
+      </p:sp>
+      <p:sp>
+        <p:nvSpPr>
+          <p:cNvPr id="11" name="TextBox 10"/>
+          <p:cNvSpPr txBox="1"/>
+          <p:nvPr/>
+        </p:nvSpPr>
+        <p:spPr>
+          <a:xfrm>
+            <a:off x="1645920" y="3538728"/>
+            <a:ext cx="5669280" cy="548640"/>
+          </a:xfrm>
+          <a:prstGeom prst="rect">
+            <a:avLst/>
+          </a:prstGeom>
+          <a:noFill/>
+        </p:spPr>
+        <p:txBody>
+          <a:bodyPr wrap="square" anchor="t" lIns="0" rIns="0" tIns="0" bIns="0">
+            <a:spAutoFit/>
+          </a:bodyPr>
+          <a:lstStyle/>
+          <a:p>
+            <a:pPr algn="l">
+              <a:spcAft>
+                <a:spcPts val="675"/>
+              </a:spcAft>
+            </a:pPr>
+            <a:r>
+              <a:rPr sz="1500" b="0" i="0">
                 <a:solidFill>
                   <a:srgbClr val="1A1A1A"/>
                 </a:solidFill>
                 <a:latin typeface="Calibri"/>
               </a:rPr>
-              <a:t>NJ: 868 ms per query, and the whole tree must be rebuilt for new queries.</a:t>
-            </a:r>
-          </a:p>
+              <a:t>Wrong names fall from 67% to 10% across 39 species.</a:t>
+            </a:r>
+          </a:p>
+        </p:txBody>
+      </p:sp>
+      <p:sp>
+        <p:nvSpPr>
+          <p:cNvPr id="12" name="Rounded Rectangle 11"/>
+          <p:cNvSpPr/>
+          <p:nvPr/>
+        </p:nvSpPr>
+        <p:spPr>
+          <a:xfrm>
+            <a:off x="548640" y="4343400"/>
+            <a:ext cx="6949440" cy="1280160"/>
+          </a:xfrm>
+          <a:prstGeom prst="roundRect">
+            <a:avLst>
+              <a:gd name="adj" fmla="val 8000"/>
+            </a:avLst>
+          </a:prstGeom>
+          <a:solidFill>
+            <a:srgbClr val="E6F0EF"/>
+          </a:solidFill>
+          <a:ln>
+            <a:noFill/>
+          </a:ln>
+          <a:effectLst/>
+        </p:spPr>
+        <p:style>
+          <a:lnRef idx="1">
+            <a:schemeClr val="accent1"/>
+          </a:lnRef>
+          <a:fillRef idx="3">
+            <a:schemeClr val="accent1"/>
+          </a:fillRef>
+          <a:effectRef idx="2">
+            <a:schemeClr val="accent1"/>
+          </a:effectRef>
+          <a:fontRef idx="minor">
+            <a:schemeClr val="lt1"/>
+          </a:fontRef>
+        </p:style>
+        <p:txBody>
+          <a:bodyPr rtlCol="0" anchor="ctr"/>
+          <a:lstStyle/>
+          <a:p>
+            <a:pPr algn="ctr"/>
+          </a:p>
+        </p:txBody>
+      </p:sp>
+      <p:sp>
+        <p:nvSpPr>
+          <p:cNvPr id="13" name="Oval 12"/>
+          <p:cNvSpPr/>
+          <p:nvPr/>
+        </p:nvSpPr>
+        <p:spPr>
+          <a:xfrm>
+            <a:off x="822960" y="4690872"/>
+            <a:ext cx="566928" cy="566928"/>
+          </a:xfrm>
+          <a:prstGeom prst="ellipse">
+            <a:avLst/>
+          </a:prstGeom>
+          <a:solidFill>
+            <a:srgbClr val="0F3B40"/>
+          </a:solidFill>
+          <a:ln>
+            <a:noFill/>
+          </a:ln>
+          <a:effectLst/>
+        </p:spPr>
+        <p:style>
+          <a:lnRef idx="1">
+            <a:schemeClr val="accent1"/>
+          </a:lnRef>
+          <a:fillRef idx="3">
+            <a:schemeClr val="accent1"/>
+          </a:fillRef>
+          <a:effectRef idx="2">
+            <a:schemeClr val="accent1"/>
+          </a:effectRef>
+          <a:fontRef idx="minor">
+            <a:schemeClr val="lt1"/>
+          </a:fontRef>
+        </p:style>
+        <p:txBody>
+          <a:bodyPr rtlCol="0" anchor="ctr" lIns="0" rIns="0" tIns="0" bIns="0"/>
+          <a:lstStyle/>
+          <a:p>
+            <a:pPr algn="ctr"/>
+            <a:r>
+              <a:rPr sz="1800" b="1">
+                <a:solidFill>
+                  <a:srgbClr val="FFFFFF"/>
+                </a:solidFill>
+                <a:latin typeface="Cambria"/>
+              </a:rPr>
+              <a:t>3</a:t>
+            </a:r>
+          </a:p>
+        </p:txBody>
+      </p:sp>
+      <p:sp>
+        <p:nvSpPr>
+          <p:cNvPr id="14" name="TextBox 13"/>
+          <p:cNvSpPr txBox="1"/>
+          <p:nvPr/>
+        </p:nvSpPr>
+        <p:spPr>
+          <a:xfrm>
+            <a:off x="1645920" y="4544568"/>
+            <a:ext cx="5669280" cy="457200"/>
+          </a:xfrm>
+          <a:prstGeom prst="rect">
+            <a:avLst/>
+          </a:prstGeom>
+          <a:noFill/>
+        </p:spPr>
+        <p:txBody>
+          <a:bodyPr wrap="square" anchor="t" lIns="0" rIns="0" tIns="0" bIns="0">
+            <a:spAutoFit/>
+          </a:bodyPr>
+          <a:lstStyle/>
           <a:p>
             <a:pPr algn="l">
               <a:spcAft>
-                <a:spcPts val="720"/>
-              </a:spcAft>
-            </a:pPr>
-            <a:r>
-              <a:rPr sz="1600" b="0" i="0">
+                <a:spcPts val="855"/>
+              </a:spcAft>
+            </a:pPr>
+            <a:r>
+              <a:rPr sz="1900" b="1" i="0">
+                <a:solidFill>
+                  <a:srgbClr val="0F3B40"/>
+                </a:solidFill>
+                <a:latin typeface="Calibri"/>
+              </a:rPr>
+              <a:t>Overlapping curves</a:t>
+            </a:r>
+          </a:p>
+        </p:txBody>
+      </p:sp>
+      <p:sp>
+        <p:nvSpPr>
+          <p:cNvPr id="15" name="TextBox 14"/>
+          <p:cNvSpPr txBox="1"/>
+          <p:nvPr/>
+        </p:nvSpPr>
+        <p:spPr>
+          <a:xfrm>
+            <a:off x="1645920" y="5001768"/>
+            <a:ext cx="5669280" cy="548640"/>
+          </a:xfrm>
+          <a:prstGeom prst="rect">
+            <a:avLst/>
+          </a:prstGeom>
+          <a:noFill/>
+        </p:spPr>
+        <p:txBody>
+          <a:bodyPr wrap="square" anchor="t" lIns="0" rIns="0" tIns="0" bIns="0">
+            <a:spAutoFit/>
+          </a:bodyPr>
+          <a:lstStyle/>
+          <a:p>
+            <a:pPr algn="l">
+              <a:spcAft>
+                <a:spcPts val="675"/>
+              </a:spcAft>
+            </a:pPr>
+            <a:r>
+              <a:rPr sz="1500" b="0" i="0">
                 <a:solidFill>
                   <a:srgbClr val="1A1A1A"/>
                 </a:solidFill>
                 <a:latin typeface="Calibri"/>
               </a:rPr>
-              <a:t>k-NN: 3.3 ms per query after ~1 second of training.</a:t>
+              <a:t>At equal false alarms, tree + cut-off and k-NN catch the same unknowns.</a:t>
+            </a:r>
+          </a:p>
+        </p:txBody>
+      </p:sp>
+      <p:sp>
+        <p:nvSpPr>
+          <p:cNvPr id="16" name="Rounded Rectangle 15"/>
+          <p:cNvSpPr/>
+          <p:nvPr/>
+        </p:nvSpPr>
+        <p:spPr>
+          <a:xfrm>
+            <a:off x="7863840" y="1417320"/>
+            <a:ext cx="3794760" cy="2743200"/>
+          </a:xfrm>
+          <a:prstGeom prst="roundRect">
+            <a:avLst>
+              <a:gd name="adj" fmla="val 8000"/>
+            </a:avLst>
+          </a:prstGeom>
+          <a:solidFill>
+            <a:srgbClr val="FBF1DC"/>
+          </a:solidFill>
+          <a:ln>
+            <a:noFill/>
+          </a:ln>
+          <a:effectLst/>
+        </p:spPr>
+        <p:style>
+          <a:lnRef idx="1">
+            <a:schemeClr val="accent1"/>
+          </a:lnRef>
+          <a:fillRef idx="3">
+            <a:schemeClr val="accent1"/>
+          </a:fillRef>
+          <a:effectRef idx="2">
+            <a:schemeClr val="accent1"/>
+          </a:effectRef>
+          <a:fontRef idx="minor">
+            <a:schemeClr val="lt1"/>
+          </a:fontRef>
+        </p:style>
+        <p:txBody>
+          <a:bodyPr rtlCol="0" anchor="ctr"/>
+          <a:lstStyle/>
+          <a:p>
+            <a:pPr algn="ctr"/>
+          </a:p>
+        </p:txBody>
+      </p:sp>
+      <p:sp>
+        <p:nvSpPr>
+          <p:cNvPr id="17" name="TextBox 16"/>
+          <p:cNvSpPr txBox="1"/>
+          <p:nvPr/>
+        </p:nvSpPr>
+        <p:spPr>
+          <a:xfrm>
+            <a:off x="8138160" y="1691640"/>
+            <a:ext cx="3291840" cy="2377440"/>
+          </a:xfrm>
+          <a:prstGeom prst="rect">
+            <a:avLst/>
+          </a:prstGeom>
+          <a:noFill/>
+        </p:spPr>
+        <p:txBody>
+          <a:bodyPr wrap="square" anchor="t" lIns="0" rIns="0" tIns="0" bIns="0">
+            <a:spAutoFit/>
+          </a:bodyPr>
+          <a:lstStyle/>
+          <a:p>
+            <a:pPr algn="l">
+              <a:spcAft>
+                <a:spcPts val="765"/>
+              </a:spcAft>
+            </a:pPr>
+            <a:r>
+              <a:rPr sz="1700" b="1" i="0">
+                <a:solidFill>
+                  <a:srgbClr val="0F3B40"/>
+                </a:solidFill>
+                <a:latin typeface="Calibri"/>
+              </a:rPr>
+              <a:t>The cut-off makes it safe, </a:t>
+            </a:r>
+            <a:r>
+              <a:rPr sz="1700" b="0" i="0">
+                <a:solidFill>
+                  <a:srgbClr val="1A1A1A"/>
+                </a:solidFill>
+                <a:latin typeface="Calibri"/>
+              </a:rPr>
+              <a:t>not machine learning.</a:t>
+            </a:r>
+          </a:p>
+          <a:p>
+            <a:pPr algn="l">
+              <a:spcAft>
+                <a:spcPts val="765"/>
+              </a:spcAft>
+            </a:pPr>
+            <a:r>
+              <a:rPr sz="1700" b="1" i="0">
+                <a:solidFill>
+                  <a:srgbClr val="0F3B40"/>
+                </a:solidFill>
+                <a:latin typeface="Calibri"/>
+              </a:rPr>
+              <a:t>What k-NN adds: </a:t>
+            </a:r>
+            <a:r>
+              <a:rPr sz="1700" b="0" i="0">
+                <a:solidFill>
+                  <a:srgbClr val="1A1A1A"/>
+                </a:solidFill>
+                <a:latin typeface="Calibri"/>
+              </a:rPr>
+              <a:t>~264× speed, and slightly more known species correct (88% vs 85% for the tree + cut-off).</a:t>
+            </a:r>
+          </a:p>
+          <a:p>
+            <a:pPr algn="l">
+              <a:spcAft>
+                <a:spcPts val="765"/>
+              </a:spcAft>
+            </a:pPr>
+            <a:r>
+              <a:rPr sz="1300" b="0" i="1">
+                <a:solidFill>
+                  <a:srgbClr val="5A5A55"/>
+                </a:solidFill>
+                <a:latin typeface="Calibri"/>
+              </a:rPr>
+              <a:t>Condition B main run and all 39 species.</a:t>
             </a:r>
           </a:p>
         </p:txBody>
@@ -5654,120 +5785,45 @@
                 </a:solidFill>
                 <a:latin typeface="Cambria"/>
               </a:rPr>
-              <a:t>Limitations</a:t>
-            </a:r>
-          </a:p>
-        </p:txBody>
-      </p:sp>
-      <p:sp>
-        <p:nvSpPr>
-          <p:cNvPr id="4" name="Rounded Rectangle 3"/>
-          <p:cNvSpPr/>
-          <p:nvPr/>
-        </p:nvSpPr>
-        <p:spPr>
-          <a:xfrm>
-            <a:off x="548640" y="1554480"/>
-            <a:ext cx="5349240" cy="1874519"/>
-          </a:xfrm>
-          <a:prstGeom prst="roundRect">
-            <a:avLst>
-              <a:gd name="adj" fmla="val 8000"/>
-            </a:avLst>
-          </a:prstGeom>
-          <a:solidFill>
-            <a:srgbClr val="E6F0EF"/>
-          </a:solidFill>
-          <a:ln>
-            <a:noFill/>
-          </a:ln>
-          <a:effectLst/>
-        </p:spPr>
-        <p:style>
-          <a:lnRef idx="1">
-            <a:schemeClr val="accent1"/>
-          </a:lnRef>
-          <a:fillRef idx="3">
-            <a:schemeClr val="accent1"/>
-          </a:fillRef>
-          <a:effectRef idx="2">
-            <a:schemeClr val="accent1"/>
-          </a:effectRef>
-          <a:fontRef idx="minor">
-            <a:schemeClr val="lt1"/>
-          </a:fontRef>
-        </p:style>
-        <p:txBody>
-          <a:bodyPr rtlCol="0" anchor="ctr"/>
-          <a:lstStyle/>
-          <a:p>
-            <a:pPr algn="ctr"/>
-          </a:p>
-        </p:txBody>
-      </p:sp>
-      <p:sp>
-        <p:nvSpPr>
-          <p:cNvPr id="5" name="Oval 4"/>
-          <p:cNvSpPr/>
-          <p:nvPr/>
-        </p:nvSpPr>
-        <p:spPr>
-          <a:xfrm>
-            <a:off x="868680" y="1874519"/>
-            <a:ext cx="566928" cy="566928"/>
-          </a:xfrm>
-          <a:prstGeom prst="ellipse">
-            <a:avLst/>
-          </a:prstGeom>
-          <a:solidFill>
-            <a:srgbClr val="0F3B40"/>
-          </a:solidFill>
-          <a:ln>
-            <a:noFill/>
-          </a:ln>
-          <a:effectLst/>
-        </p:spPr>
-        <p:style>
-          <a:lnRef idx="1">
-            <a:schemeClr val="accent1"/>
-          </a:lnRef>
-          <a:fillRef idx="3">
-            <a:schemeClr val="accent1"/>
-          </a:fillRef>
-          <a:effectRef idx="2">
-            <a:schemeClr val="accent1"/>
-          </a:effectRef>
-          <a:fontRef idx="minor">
-            <a:schemeClr val="lt1"/>
-          </a:fontRef>
-        </p:style>
-        <p:txBody>
-          <a:bodyPr rtlCol="0" anchor="ctr" lIns="0" rIns="0" tIns="0" bIns="0"/>
-          <a:lstStyle/>
-          <a:p>
-            <a:pPr algn="ctr"/>
-            <a:r>
-              <a:rPr sz="1800" b="1">
-                <a:solidFill>
-                  <a:srgbClr val="FFFFFF"/>
-                </a:solidFill>
-                <a:latin typeface="Cambria"/>
-              </a:rPr>
-              <a:t>1</a:t>
-            </a:r>
-          </a:p>
-        </p:txBody>
-      </p:sp>
-      <p:sp>
-        <p:nvSpPr>
-          <p:cNvPr id="6" name="TextBox 5"/>
+              <a:t>Speed: about 260 times faster</a:t>
+            </a:r>
+          </a:p>
+        </p:txBody>
+      </p:sp>
+      <p:pic>
+        <p:nvPicPr>
+          <p:cNvPr id="4" name="Picture 3" descr="runtime.png"/>
+          <p:cNvPicPr>
+            <a:picLocks noChangeAspect="1"/>
+          </p:cNvPicPr>
+          <p:nvPr/>
+        </p:nvPicPr>
+        <p:blipFill>
+          <a:blip r:embed="rId3"/>
+          <a:stretch>
+            <a:fillRect/>
+          </a:stretch>
+        </p:blipFill>
+        <p:spPr>
+          <a:xfrm>
+            <a:off x="457200" y="1371600"/>
+            <a:ext cx="7315200" cy="4598125"/>
+          </a:xfrm>
+          <a:prstGeom prst="rect">
+            <a:avLst/>
+          </a:prstGeom>
+        </p:spPr>
+      </p:pic>
+      <p:sp>
+        <p:nvSpPr>
+          <p:cNvPr id="5" name="TextBox 4"/>
           <p:cNvSpPr txBox="1"/>
           <p:nvPr/>
         </p:nvSpPr>
         <p:spPr>
           <a:xfrm>
-            <a:off x="1691640" y="1874519"/>
-            <a:ext cx="3931920" cy="457200"/>
+            <a:off x="8229600" y="1554480"/>
+            <a:ext cx="3566160" cy="868680"/>
           </a:xfrm>
           <a:prstGeom prst="rect">
             <a:avLst/>
@@ -5782,31 +5838,31 @@
           <a:p>
             <a:pPr algn="l">
               <a:spcAft>
-                <a:spcPts val="900"/>
-              </a:spcAft>
-            </a:pPr>
-            <a:r>
-              <a:rPr sz="2000" b="1" i="0">
-                <a:solidFill>
-                  <a:srgbClr val="0F3B40"/>
-                </a:solidFill>
-                <a:latin typeface="Calibri"/>
-              </a:rPr>
-              <a:t>One group, one gene</a:t>
-            </a:r>
-          </a:p>
-        </p:txBody>
-      </p:sp>
-      <p:sp>
-        <p:nvSpPr>
-          <p:cNvPr id="7" name="TextBox 6"/>
+                <a:spcPts val="2700"/>
+              </a:spcAft>
+            </a:pPr>
+            <a:r>
+              <a:rPr sz="6000" b="1" i="0">
+                <a:solidFill>
+                  <a:srgbClr val="E09F1F"/>
+                </a:solidFill>
+                <a:latin typeface="Cambria"/>
+              </a:rPr>
+              <a:t>264×</a:t>
+            </a:r>
+          </a:p>
+        </p:txBody>
+      </p:sp>
+      <p:sp>
+        <p:nvSpPr>
+          <p:cNvPr id="6" name="TextBox 5"/>
           <p:cNvSpPr txBox="1"/>
           <p:nvPr/>
         </p:nvSpPr>
         <p:spPr>
           <a:xfrm>
-            <a:off x="1691640" y="2423160"/>
-            <a:ext cx="3931920" cy="914400"/>
+            <a:off x="8229600" y="2423160"/>
+            <a:ext cx="3566160" cy="731520"/>
           </a:xfrm>
           <a:prstGeom prst="rect">
             <a:avLst/>
@@ -5821,130 +5877,32 @@
           <a:p>
             <a:pPr algn="l">
               <a:spcAft>
-                <a:spcPts val="720"/>
-              </a:spcAft>
-            </a:pPr>
-            <a:r>
-              <a:rPr sz="1600" b="0" i="0">
-                <a:solidFill>
-                  <a:srgbClr val="1A1A1A"/>
+                <a:spcPts val="630"/>
+              </a:spcAft>
+            </a:pPr>
+            <a:r>
+              <a:rPr sz="1400" b="0" i="0">
+                <a:solidFill>
+                  <a:srgbClr val="5A5A55"/>
                 </a:solidFill>
                 <a:latin typeface="Calibri"/>
               </a:rPr>
-              <a:t>Two European Odonata families, COI only, BOLD data of 9 Oct 2026.</a:t>
-            </a:r>
-          </a:p>
-        </p:txBody>
-      </p:sp>
-      <p:sp>
-        <p:nvSpPr>
-          <p:cNvPr id="8" name="Rounded Rectangle 7"/>
-          <p:cNvSpPr/>
-          <p:nvPr/>
-        </p:nvSpPr>
-        <p:spPr>
-          <a:xfrm>
-            <a:off x="6263640" y="1554480"/>
-            <a:ext cx="5349240" cy="1874519"/>
-          </a:xfrm>
-          <a:prstGeom prst="roundRect">
-            <a:avLst>
-              <a:gd name="adj" fmla="val 8000"/>
-            </a:avLst>
-          </a:prstGeom>
-          <a:solidFill>
-            <a:srgbClr val="E6F0EF"/>
-          </a:solidFill>
-          <a:ln>
-            <a:noFill/>
-          </a:ln>
-          <a:effectLst/>
-        </p:spPr>
-        <p:style>
-          <a:lnRef idx="1">
-            <a:schemeClr val="accent1"/>
-          </a:lnRef>
-          <a:fillRef idx="3">
-            <a:schemeClr val="accent1"/>
-          </a:fillRef>
-          <a:effectRef idx="2">
-            <a:schemeClr val="accent1"/>
-          </a:effectRef>
-          <a:fontRef idx="minor">
-            <a:schemeClr val="lt1"/>
-          </a:fontRef>
-        </p:style>
-        <p:txBody>
-          <a:bodyPr rtlCol="0" anchor="ctr"/>
-          <a:lstStyle/>
-          <a:p>
-            <a:pPr algn="ctr"/>
-          </a:p>
-        </p:txBody>
-      </p:sp>
-      <p:sp>
-        <p:nvSpPr>
-          <p:cNvPr id="9" name="Oval 8"/>
-          <p:cNvSpPr/>
-          <p:nvPr/>
-        </p:nvSpPr>
-        <p:spPr>
-          <a:xfrm>
-            <a:off x="6583679" y="1874519"/>
-            <a:ext cx="566928" cy="566928"/>
-          </a:xfrm>
-          <a:prstGeom prst="ellipse">
-            <a:avLst/>
-          </a:prstGeom>
-          <a:solidFill>
-            <a:srgbClr val="0F3B40"/>
-          </a:solidFill>
-          <a:ln>
-            <a:noFill/>
-          </a:ln>
-          <a:effectLst/>
-        </p:spPr>
-        <p:style>
-          <a:lnRef idx="1">
-            <a:schemeClr val="accent1"/>
-          </a:lnRef>
-          <a:fillRef idx="3">
-            <a:schemeClr val="accent1"/>
-          </a:fillRef>
-          <a:effectRef idx="2">
-            <a:schemeClr val="accent1"/>
-          </a:effectRef>
-          <a:fontRef idx="minor">
-            <a:schemeClr val="lt1"/>
-          </a:fontRef>
-        </p:style>
-        <p:txBody>
-          <a:bodyPr rtlCol="0" anchor="ctr" lIns="0" rIns="0" tIns="0" bIns="0"/>
-          <a:lstStyle/>
-          <a:p>
-            <a:pPr algn="ctr"/>
-            <a:r>
-              <a:rPr sz="1800" b="1">
-                <a:solidFill>
-                  <a:srgbClr val="FFFFFF"/>
-                </a:solidFill>
-                <a:latin typeface="Cambria"/>
-              </a:rPr>
-              <a:t>2</a:t>
-            </a:r>
-          </a:p>
-        </p:txBody>
-      </p:sp>
-      <p:sp>
-        <p:nvSpPr>
-          <p:cNvPr id="10" name="TextBox 9"/>
+              <a:t>faster per query:
+k-NN vs the NJ tree</a:t>
+            </a:r>
+          </a:p>
+        </p:txBody>
+      </p:sp>
+      <p:sp>
+        <p:nvSpPr>
+          <p:cNvPr id="7" name="TextBox 6"/>
           <p:cNvSpPr txBox="1"/>
           <p:nvPr/>
         </p:nvSpPr>
         <p:spPr>
           <a:xfrm>
-            <a:off x="7406640" y="1874519"/>
-            <a:ext cx="3931920" cy="457200"/>
+            <a:off x="8229600" y="3429000"/>
+            <a:ext cx="3566160" cy="2377440"/>
           </a:xfrm>
           <a:prstGeom prst="rect">
             <a:avLst/>
@@ -5959,42 +5917,19 @@
           <a:p>
             <a:pPr algn="l">
               <a:spcAft>
-                <a:spcPts val="900"/>
-              </a:spcAft>
-            </a:pPr>
-            <a:r>
-              <a:rPr sz="2000" b="1" i="0">
-                <a:solidFill>
-                  <a:srgbClr val="0F3B40"/>
+                <a:spcPts val="720"/>
+              </a:spcAft>
+            </a:pPr>
+            <a:r>
+              <a:rPr sz="1600" b="0" i="0">
+                <a:solidFill>
+                  <a:srgbClr val="1A1A1A"/>
                 </a:solidFill>
                 <a:latin typeface="Calibri"/>
               </a:rPr>
-              <a:t>Small dataset</a:t>
-            </a:r>
-          </a:p>
-        </p:txBody>
-      </p:sp>
-      <p:sp>
-        <p:nvSpPr>
-          <p:cNvPr id="11" name="TextBox 10"/>
-          <p:cNvSpPr txBox="1"/>
-          <p:nvPr/>
-        </p:nvSpPr>
-        <p:spPr>
-          <a:xfrm>
-            <a:off x="7406640" y="2423160"/>
-            <a:ext cx="3931920" cy="914400"/>
-          </a:xfrm>
-          <a:prstGeom prst="rect">
-            <a:avLst/>
-          </a:prstGeom>
-          <a:noFill/>
-        </p:spPr>
-        <p:txBody>
-          <a:bodyPr wrap="square" anchor="t" lIns="0" rIns="0" tIns="0" bIns="0">
-            <a:spAutoFit/>
-          </a:bodyPr>
-          <a:lstStyle/>
+              <a:t>NJ: 868 ms per query, and the whole tree must be rebuilt for new queries.</a:t>
+            </a:r>
+          </a:p>
           <a:p>
             <a:pPr algn="l">
               <a:spcAft>
@@ -6008,361 +5943,7 @@
                 </a:solidFill>
                 <a:latin typeface="Calibri"/>
               </a:rPr>
-              <a:t>779 sequences of 45 species; some species have only 3.</a:t>
-            </a:r>
-          </a:p>
-        </p:txBody>
-      </p:sp>
-      <p:sp>
-        <p:nvSpPr>
-          <p:cNvPr id="12" name="Rounded Rectangle 11"/>
-          <p:cNvSpPr/>
-          <p:nvPr/>
-        </p:nvSpPr>
-        <p:spPr>
-          <a:xfrm>
-            <a:off x="548640" y="3749039"/>
-            <a:ext cx="5349240" cy="1874519"/>
-          </a:xfrm>
-          <a:prstGeom prst="roundRect">
-            <a:avLst>
-              <a:gd name="adj" fmla="val 8000"/>
-            </a:avLst>
-          </a:prstGeom>
-          <a:solidFill>
-            <a:srgbClr val="E6F0EF"/>
-          </a:solidFill>
-          <a:ln>
-            <a:noFill/>
-          </a:ln>
-          <a:effectLst/>
-        </p:spPr>
-        <p:style>
-          <a:lnRef idx="1">
-            <a:schemeClr val="accent1"/>
-          </a:lnRef>
-          <a:fillRef idx="3">
-            <a:schemeClr val="accent1"/>
-          </a:fillRef>
-          <a:effectRef idx="2">
-            <a:schemeClr val="accent1"/>
-          </a:effectRef>
-          <a:fontRef idx="minor">
-            <a:schemeClr val="lt1"/>
-          </a:fontRef>
-        </p:style>
-        <p:txBody>
-          <a:bodyPr rtlCol="0" anchor="ctr"/>
-          <a:lstStyle/>
-          <a:p>
-            <a:pPr algn="ctr"/>
-          </a:p>
-        </p:txBody>
-      </p:sp>
-      <p:sp>
-        <p:nvSpPr>
-          <p:cNvPr id="13" name="Oval 12"/>
-          <p:cNvSpPr/>
-          <p:nvPr/>
-        </p:nvSpPr>
-        <p:spPr>
-          <a:xfrm>
-            <a:off x="868680" y="4069079"/>
-            <a:ext cx="566928" cy="566928"/>
-          </a:xfrm>
-          <a:prstGeom prst="ellipse">
-            <a:avLst/>
-          </a:prstGeom>
-          <a:solidFill>
-            <a:srgbClr val="0F3B40"/>
-          </a:solidFill>
-          <a:ln>
-            <a:noFill/>
-          </a:ln>
-          <a:effectLst/>
-        </p:spPr>
-        <p:style>
-          <a:lnRef idx="1">
-            <a:schemeClr val="accent1"/>
-          </a:lnRef>
-          <a:fillRef idx="3">
-            <a:schemeClr val="accent1"/>
-          </a:fillRef>
-          <a:effectRef idx="2">
-            <a:schemeClr val="accent1"/>
-          </a:effectRef>
-          <a:fontRef idx="minor">
-            <a:schemeClr val="lt1"/>
-          </a:fontRef>
-        </p:style>
-        <p:txBody>
-          <a:bodyPr rtlCol="0" anchor="ctr" lIns="0" rIns="0" tIns="0" bIns="0"/>
-          <a:lstStyle/>
-          <a:p>
-            <a:pPr algn="ctr"/>
-            <a:r>
-              <a:rPr sz="1800" b="1">
-                <a:solidFill>
-                  <a:srgbClr val="FFFFFF"/>
-                </a:solidFill>
-                <a:latin typeface="Cambria"/>
-              </a:rPr>
-              <a:t>3</a:t>
-            </a:r>
-          </a:p>
-        </p:txBody>
-      </p:sp>
-      <p:sp>
-        <p:nvSpPr>
-          <p:cNvPr id="14" name="TextBox 13"/>
-          <p:cNvSpPr txBox="1"/>
-          <p:nvPr/>
-        </p:nvSpPr>
-        <p:spPr>
-          <a:xfrm>
-            <a:off x="1691640" y="4069079"/>
-            <a:ext cx="3931920" cy="457200"/>
-          </a:xfrm>
-          <a:prstGeom prst="rect">
-            <a:avLst/>
-          </a:prstGeom>
-          <a:noFill/>
-        </p:spPr>
-        <p:txBody>
-          <a:bodyPr wrap="square" anchor="t" lIns="0" rIns="0" tIns="0" bIns="0">
-            <a:spAutoFit/>
-          </a:bodyPr>
-          <a:lstStyle/>
-          <a:p>
-            <a:pPr algn="l">
-              <a:spcAft>
-                <a:spcPts val="900"/>
-              </a:spcAft>
-            </a:pPr>
-            <a:r>
-              <a:rPr sz="2000" b="1" i="0">
-                <a:solidFill>
-                  <a:srgbClr val="0F3B40"/>
-                </a:solidFill>
-                <a:latin typeface="Calibri"/>
-              </a:rPr>
-              <a:t>Barcode sharing</a:t>
-            </a:r>
-          </a:p>
-        </p:txBody>
-      </p:sp>
-      <p:sp>
-        <p:nvSpPr>
-          <p:cNvPr id="15" name="TextBox 14"/>
-          <p:cNvSpPr txBox="1"/>
-          <p:nvPr/>
-        </p:nvSpPr>
-        <p:spPr>
-          <a:xfrm>
-            <a:off x="1691640" y="4617720"/>
-            <a:ext cx="3931920" cy="914400"/>
-          </a:xfrm>
-          <a:prstGeom prst="rect">
-            <a:avLst/>
-          </a:prstGeom>
-          <a:noFill/>
-        </p:spPr>
-        <p:txBody>
-          <a:bodyPr wrap="square" anchor="t" lIns="0" rIns="0" tIns="0" bIns="0">
-            <a:spAutoFit/>
-          </a:bodyPr>
-          <a:lstStyle/>
-          <a:p>
-            <a:pPr algn="l">
-              <a:spcAft>
-                <a:spcPts val="720"/>
-              </a:spcAft>
-            </a:pPr>
-            <a:r>
-              <a:rPr sz="1600" b="0" i="0">
-                <a:solidFill>
-                  <a:srgbClr val="1A1A1A"/>
-                </a:solidFill>
-                <a:latin typeface="Calibri"/>
-              </a:rPr>
-              <a:t>10 species can't be separated by any barcode-only method.</a:t>
-            </a:r>
-          </a:p>
-        </p:txBody>
-      </p:sp>
-      <p:sp>
-        <p:nvSpPr>
-          <p:cNvPr id="16" name="Rounded Rectangle 15"/>
-          <p:cNvSpPr/>
-          <p:nvPr/>
-        </p:nvSpPr>
-        <p:spPr>
-          <a:xfrm>
-            <a:off x="6263640" y="3749039"/>
-            <a:ext cx="5349240" cy="1874519"/>
-          </a:xfrm>
-          <a:prstGeom prst="roundRect">
-            <a:avLst>
-              <a:gd name="adj" fmla="val 8000"/>
-            </a:avLst>
-          </a:prstGeom>
-          <a:solidFill>
-            <a:srgbClr val="E6F0EF"/>
-          </a:solidFill>
-          <a:ln>
-            <a:noFill/>
-          </a:ln>
-          <a:effectLst/>
-        </p:spPr>
-        <p:style>
-          <a:lnRef idx="1">
-            <a:schemeClr val="accent1"/>
-          </a:lnRef>
-          <a:fillRef idx="3">
-            <a:schemeClr val="accent1"/>
-          </a:fillRef>
-          <a:effectRef idx="2">
-            <a:schemeClr val="accent1"/>
-          </a:effectRef>
-          <a:fontRef idx="minor">
-            <a:schemeClr val="lt1"/>
-          </a:fontRef>
-        </p:style>
-        <p:txBody>
-          <a:bodyPr rtlCol="0" anchor="ctr"/>
-          <a:lstStyle/>
-          <a:p>
-            <a:pPr algn="ctr"/>
-          </a:p>
-        </p:txBody>
-      </p:sp>
-      <p:sp>
-        <p:nvSpPr>
-          <p:cNvPr id="17" name="Oval 16"/>
-          <p:cNvSpPr/>
-          <p:nvPr/>
-        </p:nvSpPr>
-        <p:spPr>
-          <a:xfrm>
-            <a:off x="6583679" y="4069079"/>
-            <a:ext cx="566928" cy="566928"/>
-          </a:xfrm>
-          <a:prstGeom prst="ellipse">
-            <a:avLst/>
-          </a:prstGeom>
-          <a:solidFill>
-            <a:srgbClr val="0F3B40"/>
-          </a:solidFill>
-          <a:ln>
-            <a:noFill/>
-          </a:ln>
-          <a:effectLst/>
-        </p:spPr>
-        <p:style>
-          <a:lnRef idx="1">
-            <a:schemeClr val="accent1"/>
-          </a:lnRef>
-          <a:fillRef idx="3">
-            <a:schemeClr val="accent1"/>
-          </a:fillRef>
-          <a:effectRef idx="2">
-            <a:schemeClr val="accent1"/>
-          </a:effectRef>
-          <a:fontRef idx="minor">
-            <a:schemeClr val="lt1"/>
-          </a:fontRef>
-        </p:style>
-        <p:txBody>
-          <a:bodyPr rtlCol="0" anchor="ctr" lIns="0" rIns="0" tIns="0" bIns="0"/>
-          <a:lstStyle/>
-          <a:p>
-            <a:pPr algn="ctr"/>
-            <a:r>
-              <a:rPr sz="1800" b="1">
-                <a:solidFill>
-                  <a:srgbClr val="FFFFFF"/>
-                </a:solidFill>
-                <a:latin typeface="Cambria"/>
-              </a:rPr>
-              <a:t>4</a:t>
-            </a:r>
-          </a:p>
-        </p:txBody>
-      </p:sp>
-      <p:sp>
-        <p:nvSpPr>
-          <p:cNvPr id="18" name="TextBox 17"/>
-          <p:cNvSpPr txBox="1"/>
-          <p:nvPr/>
-        </p:nvSpPr>
-        <p:spPr>
-          <a:xfrm>
-            <a:off x="7406640" y="4069079"/>
-            <a:ext cx="3931920" cy="457200"/>
-          </a:xfrm>
-          <a:prstGeom prst="rect">
-            <a:avLst/>
-          </a:prstGeom>
-          <a:noFill/>
-        </p:spPr>
-        <p:txBody>
-          <a:bodyPr wrap="square" anchor="t" lIns="0" rIns="0" tIns="0" bIns="0">
-            <a:spAutoFit/>
-          </a:bodyPr>
-          <a:lstStyle/>
-          <a:p>
-            <a:pPr algn="l">
-              <a:spcAft>
-                <a:spcPts val="900"/>
-              </a:spcAft>
-            </a:pPr>
-            <a:r>
-              <a:rPr sz="2000" b="1" i="0">
-                <a:solidFill>
-                  <a:srgbClr val="0F3B40"/>
-                </a:solidFill>
-                <a:latin typeface="Calibri"/>
-              </a:rPr>
-              <a:t>Tree not fully like-for-like</a:t>
-            </a:r>
-          </a:p>
-        </p:txBody>
-      </p:sp>
-      <p:sp>
-        <p:nvSpPr>
-          <p:cNvPr id="19" name="TextBox 18"/>
-          <p:cNvSpPr txBox="1"/>
-          <p:nvPr/>
-        </p:nvSpPr>
-        <p:spPr>
-          <a:xfrm>
-            <a:off x="7406640" y="4617720"/>
-            <a:ext cx="3931920" cy="914400"/>
-          </a:xfrm>
-          <a:prstGeom prst="rect">
-            <a:avLst/>
-          </a:prstGeom>
-          <a:noFill/>
-        </p:spPr>
-        <p:txBody>
-          <a:bodyPr wrap="square" anchor="t" lIns="0" rIns="0" tIns="0" bIns="0">
-            <a:spAutoFit/>
-          </a:bodyPr>
-          <a:lstStyle/>
-          <a:p>
-            <a:pPr algn="l">
-              <a:spcAft>
-                <a:spcPts val="720"/>
-              </a:spcAft>
-            </a:pPr>
-            <a:r>
-              <a:rPr sz="1600" b="0" i="0">
-                <a:solidFill>
-                  <a:srgbClr val="1A1A1A"/>
-                </a:solidFill>
-                <a:latin typeface="Calibri"/>
-              </a:rPr>
-              <a:t>NJ had no extra 'unknown' threshold; one tree for all queries.</a:t>
+              <a:t>k-NN: 3.3 ms per query after ~1 second of training.</a:t>
             </a:r>
           </a:p>
         </p:txBody>
@@ -6376,6 +5957,818 @@
 </file>
 
 <file path=ppt/slides/slide13.xml><?xml version="1.0" encoding="utf-8"?>
+<p:sld xmlns:a="http://schemas.openxmlformats.org/drawingml/2006/main" xmlns:p="http://schemas.openxmlformats.org/presentationml/2006/main" xmlns:r="http://schemas.openxmlformats.org/officeDocument/2006/relationships">
+  <p:cSld>
+    <p:bg>
+      <p:bgPr>
+        <a:solidFill>
+          <a:srgbClr val="FFFFFF"/>
+        </a:solidFill>
+        <a:effectLst/>
+      </p:bgPr>
+    </p:bg>
+    <p:spTree>
+      <p:nvGrpSpPr>
+        <p:cNvPr id="1" name=""/>
+        <p:cNvGrpSpPr/>
+        <p:nvPr/>
+      </p:nvGrpSpPr>
+      <p:grpSpPr/>
+      <p:sp>
+        <p:nvSpPr>
+          <p:cNvPr id="2" name="TextBox 1"/>
+          <p:cNvSpPr txBox="1"/>
+          <p:nvPr/>
+        </p:nvSpPr>
+        <p:spPr>
+          <a:xfrm>
+            <a:off x="11277295" y="6400800"/>
+            <a:ext cx="457200" cy="274320"/>
+          </a:xfrm>
+          <a:prstGeom prst="rect">
+            <a:avLst/>
+          </a:prstGeom>
+          <a:noFill/>
+        </p:spPr>
+        <p:txBody>
+          <a:bodyPr wrap="square" anchor="t" lIns="0" rIns="0" tIns="0" bIns="0">
+            <a:spAutoFit/>
+          </a:bodyPr>
+          <a:lstStyle/>
+          <a:p>
+            <a:pPr algn="r">
+              <a:spcAft>
+                <a:spcPts val="450"/>
+              </a:spcAft>
+            </a:pPr>
+            <a:r>
+              <a:rPr sz="1000" b="0" i="0">
+                <a:solidFill>
+                  <a:srgbClr val="5A5A55"/>
+                </a:solidFill>
+                <a:latin typeface="Calibri"/>
+              </a:rPr>
+              <a:t>13</a:t>
+            </a:r>
+          </a:p>
+        </p:txBody>
+      </p:sp>
+      <p:sp>
+        <p:nvSpPr>
+          <p:cNvPr id="3" name="TextBox 2"/>
+          <p:cNvSpPr txBox="1"/>
+          <p:nvPr/>
+        </p:nvSpPr>
+        <p:spPr>
+          <a:xfrm>
+            <a:off x="548640" y="411480"/>
+            <a:ext cx="11094415" cy="822960"/>
+          </a:xfrm>
+          <a:prstGeom prst="rect">
+            <a:avLst/>
+          </a:prstGeom>
+          <a:noFill/>
+        </p:spPr>
+        <p:txBody>
+          <a:bodyPr wrap="square" anchor="t" lIns="0" rIns="0" tIns="0" bIns="0">
+            <a:spAutoFit/>
+          </a:bodyPr>
+          <a:lstStyle/>
+          <a:p>
+            <a:pPr algn="l">
+              <a:spcAft>
+                <a:spcPts val="1530"/>
+              </a:spcAft>
+            </a:pPr>
+            <a:r>
+              <a:rPr sz="3400" b="1" i="0">
+                <a:solidFill>
+                  <a:srgbClr val="0F3B40"/>
+                </a:solidFill>
+                <a:latin typeface="Cambria"/>
+              </a:rPr>
+              <a:t>Limitations</a:t>
+            </a:r>
+          </a:p>
+        </p:txBody>
+      </p:sp>
+      <p:sp>
+        <p:nvSpPr>
+          <p:cNvPr id="4" name="Rounded Rectangle 3"/>
+          <p:cNvSpPr/>
+          <p:nvPr/>
+        </p:nvSpPr>
+        <p:spPr>
+          <a:xfrm>
+            <a:off x="548640" y="1554480"/>
+            <a:ext cx="5349240" cy="1874519"/>
+          </a:xfrm>
+          <a:prstGeom prst="roundRect">
+            <a:avLst>
+              <a:gd name="adj" fmla="val 8000"/>
+            </a:avLst>
+          </a:prstGeom>
+          <a:solidFill>
+            <a:srgbClr val="E6F0EF"/>
+          </a:solidFill>
+          <a:ln>
+            <a:noFill/>
+          </a:ln>
+          <a:effectLst/>
+        </p:spPr>
+        <p:style>
+          <a:lnRef idx="1">
+            <a:schemeClr val="accent1"/>
+          </a:lnRef>
+          <a:fillRef idx="3">
+            <a:schemeClr val="accent1"/>
+          </a:fillRef>
+          <a:effectRef idx="2">
+            <a:schemeClr val="accent1"/>
+          </a:effectRef>
+          <a:fontRef idx="minor">
+            <a:schemeClr val="lt1"/>
+          </a:fontRef>
+        </p:style>
+        <p:txBody>
+          <a:bodyPr rtlCol="0" anchor="ctr"/>
+          <a:lstStyle/>
+          <a:p>
+            <a:pPr algn="ctr"/>
+          </a:p>
+        </p:txBody>
+      </p:sp>
+      <p:sp>
+        <p:nvSpPr>
+          <p:cNvPr id="5" name="Oval 4"/>
+          <p:cNvSpPr/>
+          <p:nvPr/>
+        </p:nvSpPr>
+        <p:spPr>
+          <a:xfrm>
+            <a:off x="868680" y="1874519"/>
+            <a:ext cx="566928" cy="566928"/>
+          </a:xfrm>
+          <a:prstGeom prst="ellipse">
+            <a:avLst/>
+          </a:prstGeom>
+          <a:solidFill>
+            <a:srgbClr val="0F3B40"/>
+          </a:solidFill>
+          <a:ln>
+            <a:noFill/>
+          </a:ln>
+          <a:effectLst/>
+        </p:spPr>
+        <p:style>
+          <a:lnRef idx="1">
+            <a:schemeClr val="accent1"/>
+          </a:lnRef>
+          <a:fillRef idx="3">
+            <a:schemeClr val="accent1"/>
+          </a:fillRef>
+          <a:effectRef idx="2">
+            <a:schemeClr val="accent1"/>
+          </a:effectRef>
+          <a:fontRef idx="minor">
+            <a:schemeClr val="lt1"/>
+          </a:fontRef>
+        </p:style>
+        <p:txBody>
+          <a:bodyPr rtlCol="0" anchor="ctr" lIns="0" rIns="0" tIns="0" bIns="0"/>
+          <a:lstStyle/>
+          <a:p>
+            <a:pPr algn="ctr"/>
+            <a:r>
+              <a:rPr sz="1800" b="1">
+                <a:solidFill>
+                  <a:srgbClr val="FFFFFF"/>
+                </a:solidFill>
+                <a:latin typeface="Cambria"/>
+              </a:rPr>
+              <a:t>1</a:t>
+            </a:r>
+          </a:p>
+        </p:txBody>
+      </p:sp>
+      <p:sp>
+        <p:nvSpPr>
+          <p:cNvPr id="6" name="TextBox 5"/>
+          <p:cNvSpPr txBox="1"/>
+          <p:nvPr/>
+        </p:nvSpPr>
+        <p:spPr>
+          <a:xfrm>
+            <a:off x="1691640" y="1874519"/>
+            <a:ext cx="3931920" cy="457200"/>
+          </a:xfrm>
+          <a:prstGeom prst="rect">
+            <a:avLst/>
+          </a:prstGeom>
+          <a:noFill/>
+        </p:spPr>
+        <p:txBody>
+          <a:bodyPr wrap="square" anchor="t" lIns="0" rIns="0" tIns="0" bIns="0">
+            <a:spAutoFit/>
+          </a:bodyPr>
+          <a:lstStyle/>
+          <a:p>
+            <a:pPr algn="l">
+              <a:spcAft>
+                <a:spcPts val="900"/>
+              </a:spcAft>
+            </a:pPr>
+            <a:r>
+              <a:rPr sz="2000" b="1" i="0">
+                <a:solidFill>
+                  <a:srgbClr val="0F3B40"/>
+                </a:solidFill>
+                <a:latin typeface="Calibri"/>
+              </a:rPr>
+              <a:t>One group, one gene</a:t>
+            </a:r>
+          </a:p>
+        </p:txBody>
+      </p:sp>
+      <p:sp>
+        <p:nvSpPr>
+          <p:cNvPr id="7" name="TextBox 6"/>
+          <p:cNvSpPr txBox="1"/>
+          <p:nvPr/>
+        </p:nvSpPr>
+        <p:spPr>
+          <a:xfrm>
+            <a:off x="1691640" y="2423160"/>
+            <a:ext cx="3931920" cy="914400"/>
+          </a:xfrm>
+          <a:prstGeom prst="rect">
+            <a:avLst/>
+          </a:prstGeom>
+          <a:noFill/>
+        </p:spPr>
+        <p:txBody>
+          <a:bodyPr wrap="square" anchor="t" lIns="0" rIns="0" tIns="0" bIns="0">
+            <a:spAutoFit/>
+          </a:bodyPr>
+          <a:lstStyle/>
+          <a:p>
+            <a:pPr algn="l">
+              <a:spcAft>
+                <a:spcPts val="720"/>
+              </a:spcAft>
+            </a:pPr>
+            <a:r>
+              <a:rPr sz="1600" b="0" i="0">
+                <a:solidFill>
+                  <a:srgbClr val="1A1A1A"/>
+                </a:solidFill>
+                <a:latin typeface="Calibri"/>
+              </a:rPr>
+              <a:t>Two European Odonata families, COI only, BOLD data of 9 Oct 2026.</a:t>
+            </a:r>
+          </a:p>
+        </p:txBody>
+      </p:sp>
+      <p:sp>
+        <p:nvSpPr>
+          <p:cNvPr id="8" name="Rounded Rectangle 7"/>
+          <p:cNvSpPr/>
+          <p:nvPr/>
+        </p:nvSpPr>
+        <p:spPr>
+          <a:xfrm>
+            <a:off x="6263640" y="1554480"/>
+            <a:ext cx="5349240" cy="1874519"/>
+          </a:xfrm>
+          <a:prstGeom prst="roundRect">
+            <a:avLst>
+              <a:gd name="adj" fmla="val 8000"/>
+            </a:avLst>
+          </a:prstGeom>
+          <a:solidFill>
+            <a:srgbClr val="E6F0EF"/>
+          </a:solidFill>
+          <a:ln>
+            <a:noFill/>
+          </a:ln>
+          <a:effectLst/>
+        </p:spPr>
+        <p:style>
+          <a:lnRef idx="1">
+            <a:schemeClr val="accent1"/>
+          </a:lnRef>
+          <a:fillRef idx="3">
+            <a:schemeClr val="accent1"/>
+          </a:fillRef>
+          <a:effectRef idx="2">
+            <a:schemeClr val="accent1"/>
+          </a:effectRef>
+          <a:fontRef idx="minor">
+            <a:schemeClr val="lt1"/>
+          </a:fontRef>
+        </p:style>
+        <p:txBody>
+          <a:bodyPr rtlCol="0" anchor="ctr"/>
+          <a:lstStyle/>
+          <a:p>
+            <a:pPr algn="ctr"/>
+          </a:p>
+        </p:txBody>
+      </p:sp>
+      <p:sp>
+        <p:nvSpPr>
+          <p:cNvPr id="9" name="Oval 8"/>
+          <p:cNvSpPr/>
+          <p:nvPr/>
+        </p:nvSpPr>
+        <p:spPr>
+          <a:xfrm>
+            <a:off x="6583679" y="1874519"/>
+            <a:ext cx="566928" cy="566928"/>
+          </a:xfrm>
+          <a:prstGeom prst="ellipse">
+            <a:avLst/>
+          </a:prstGeom>
+          <a:solidFill>
+            <a:srgbClr val="0F3B40"/>
+          </a:solidFill>
+          <a:ln>
+            <a:noFill/>
+          </a:ln>
+          <a:effectLst/>
+        </p:spPr>
+        <p:style>
+          <a:lnRef idx="1">
+            <a:schemeClr val="accent1"/>
+          </a:lnRef>
+          <a:fillRef idx="3">
+            <a:schemeClr val="accent1"/>
+          </a:fillRef>
+          <a:effectRef idx="2">
+            <a:schemeClr val="accent1"/>
+          </a:effectRef>
+          <a:fontRef idx="minor">
+            <a:schemeClr val="lt1"/>
+          </a:fontRef>
+        </p:style>
+        <p:txBody>
+          <a:bodyPr rtlCol="0" anchor="ctr" lIns="0" rIns="0" tIns="0" bIns="0"/>
+          <a:lstStyle/>
+          <a:p>
+            <a:pPr algn="ctr"/>
+            <a:r>
+              <a:rPr sz="1800" b="1">
+                <a:solidFill>
+                  <a:srgbClr val="FFFFFF"/>
+                </a:solidFill>
+                <a:latin typeface="Cambria"/>
+              </a:rPr>
+              <a:t>2</a:t>
+            </a:r>
+          </a:p>
+        </p:txBody>
+      </p:sp>
+      <p:sp>
+        <p:nvSpPr>
+          <p:cNvPr id="10" name="TextBox 9"/>
+          <p:cNvSpPr txBox="1"/>
+          <p:nvPr/>
+        </p:nvSpPr>
+        <p:spPr>
+          <a:xfrm>
+            <a:off x="7406640" y="1874519"/>
+            <a:ext cx="3931920" cy="457200"/>
+          </a:xfrm>
+          <a:prstGeom prst="rect">
+            <a:avLst/>
+          </a:prstGeom>
+          <a:noFill/>
+        </p:spPr>
+        <p:txBody>
+          <a:bodyPr wrap="square" anchor="t" lIns="0" rIns="0" tIns="0" bIns="0">
+            <a:spAutoFit/>
+          </a:bodyPr>
+          <a:lstStyle/>
+          <a:p>
+            <a:pPr algn="l">
+              <a:spcAft>
+                <a:spcPts val="900"/>
+              </a:spcAft>
+            </a:pPr>
+            <a:r>
+              <a:rPr sz="2000" b="1" i="0">
+                <a:solidFill>
+                  <a:srgbClr val="0F3B40"/>
+                </a:solidFill>
+                <a:latin typeface="Calibri"/>
+              </a:rPr>
+              <a:t>Small dataset</a:t>
+            </a:r>
+          </a:p>
+        </p:txBody>
+      </p:sp>
+      <p:sp>
+        <p:nvSpPr>
+          <p:cNvPr id="11" name="TextBox 10"/>
+          <p:cNvSpPr txBox="1"/>
+          <p:nvPr/>
+        </p:nvSpPr>
+        <p:spPr>
+          <a:xfrm>
+            <a:off x="7406640" y="2423160"/>
+            <a:ext cx="3931920" cy="914400"/>
+          </a:xfrm>
+          <a:prstGeom prst="rect">
+            <a:avLst/>
+          </a:prstGeom>
+          <a:noFill/>
+        </p:spPr>
+        <p:txBody>
+          <a:bodyPr wrap="square" anchor="t" lIns="0" rIns="0" tIns="0" bIns="0">
+            <a:spAutoFit/>
+          </a:bodyPr>
+          <a:lstStyle/>
+          <a:p>
+            <a:pPr algn="l">
+              <a:spcAft>
+                <a:spcPts val="720"/>
+              </a:spcAft>
+            </a:pPr>
+            <a:r>
+              <a:rPr sz="1600" b="0" i="0">
+                <a:solidFill>
+                  <a:srgbClr val="1A1A1A"/>
+                </a:solidFill>
+                <a:latin typeface="Calibri"/>
+              </a:rPr>
+              <a:t>779 sequences of 45 species; some species have only 3.</a:t>
+            </a:r>
+          </a:p>
+        </p:txBody>
+      </p:sp>
+      <p:sp>
+        <p:nvSpPr>
+          <p:cNvPr id="12" name="Rounded Rectangle 11"/>
+          <p:cNvSpPr/>
+          <p:nvPr/>
+        </p:nvSpPr>
+        <p:spPr>
+          <a:xfrm>
+            <a:off x="548640" y="3749039"/>
+            <a:ext cx="5349240" cy="1874519"/>
+          </a:xfrm>
+          <a:prstGeom prst="roundRect">
+            <a:avLst>
+              <a:gd name="adj" fmla="val 8000"/>
+            </a:avLst>
+          </a:prstGeom>
+          <a:solidFill>
+            <a:srgbClr val="E6F0EF"/>
+          </a:solidFill>
+          <a:ln>
+            <a:noFill/>
+          </a:ln>
+          <a:effectLst/>
+        </p:spPr>
+        <p:style>
+          <a:lnRef idx="1">
+            <a:schemeClr val="accent1"/>
+          </a:lnRef>
+          <a:fillRef idx="3">
+            <a:schemeClr val="accent1"/>
+          </a:fillRef>
+          <a:effectRef idx="2">
+            <a:schemeClr val="accent1"/>
+          </a:effectRef>
+          <a:fontRef idx="minor">
+            <a:schemeClr val="lt1"/>
+          </a:fontRef>
+        </p:style>
+        <p:txBody>
+          <a:bodyPr rtlCol="0" anchor="ctr"/>
+          <a:lstStyle/>
+          <a:p>
+            <a:pPr algn="ctr"/>
+          </a:p>
+        </p:txBody>
+      </p:sp>
+      <p:sp>
+        <p:nvSpPr>
+          <p:cNvPr id="13" name="Oval 12"/>
+          <p:cNvSpPr/>
+          <p:nvPr/>
+        </p:nvSpPr>
+        <p:spPr>
+          <a:xfrm>
+            <a:off x="868680" y="4069079"/>
+            <a:ext cx="566928" cy="566928"/>
+          </a:xfrm>
+          <a:prstGeom prst="ellipse">
+            <a:avLst/>
+          </a:prstGeom>
+          <a:solidFill>
+            <a:srgbClr val="0F3B40"/>
+          </a:solidFill>
+          <a:ln>
+            <a:noFill/>
+          </a:ln>
+          <a:effectLst/>
+        </p:spPr>
+        <p:style>
+          <a:lnRef idx="1">
+            <a:schemeClr val="accent1"/>
+          </a:lnRef>
+          <a:fillRef idx="3">
+            <a:schemeClr val="accent1"/>
+          </a:fillRef>
+          <a:effectRef idx="2">
+            <a:schemeClr val="accent1"/>
+          </a:effectRef>
+          <a:fontRef idx="minor">
+            <a:schemeClr val="lt1"/>
+          </a:fontRef>
+        </p:style>
+        <p:txBody>
+          <a:bodyPr rtlCol="0" anchor="ctr" lIns="0" rIns="0" tIns="0" bIns="0"/>
+          <a:lstStyle/>
+          <a:p>
+            <a:pPr algn="ctr"/>
+            <a:r>
+              <a:rPr sz="1800" b="1">
+                <a:solidFill>
+                  <a:srgbClr val="FFFFFF"/>
+                </a:solidFill>
+                <a:latin typeface="Cambria"/>
+              </a:rPr>
+              <a:t>3</a:t>
+            </a:r>
+          </a:p>
+        </p:txBody>
+      </p:sp>
+      <p:sp>
+        <p:nvSpPr>
+          <p:cNvPr id="14" name="TextBox 13"/>
+          <p:cNvSpPr txBox="1"/>
+          <p:nvPr/>
+        </p:nvSpPr>
+        <p:spPr>
+          <a:xfrm>
+            <a:off x="1691640" y="4069079"/>
+            <a:ext cx="3931920" cy="457200"/>
+          </a:xfrm>
+          <a:prstGeom prst="rect">
+            <a:avLst/>
+          </a:prstGeom>
+          <a:noFill/>
+        </p:spPr>
+        <p:txBody>
+          <a:bodyPr wrap="square" anchor="t" lIns="0" rIns="0" tIns="0" bIns="0">
+            <a:spAutoFit/>
+          </a:bodyPr>
+          <a:lstStyle/>
+          <a:p>
+            <a:pPr algn="l">
+              <a:spcAft>
+                <a:spcPts val="900"/>
+              </a:spcAft>
+            </a:pPr>
+            <a:r>
+              <a:rPr sz="2000" b="1" i="0">
+                <a:solidFill>
+                  <a:srgbClr val="0F3B40"/>
+                </a:solidFill>
+                <a:latin typeface="Calibri"/>
+              </a:rPr>
+              <a:t>Barcode sharing</a:t>
+            </a:r>
+          </a:p>
+        </p:txBody>
+      </p:sp>
+      <p:sp>
+        <p:nvSpPr>
+          <p:cNvPr id="15" name="TextBox 14"/>
+          <p:cNvSpPr txBox="1"/>
+          <p:nvPr/>
+        </p:nvSpPr>
+        <p:spPr>
+          <a:xfrm>
+            <a:off x="1691640" y="4617720"/>
+            <a:ext cx="3931920" cy="914400"/>
+          </a:xfrm>
+          <a:prstGeom prst="rect">
+            <a:avLst/>
+          </a:prstGeom>
+          <a:noFill/>
+        </p:spPr>
+        <p:txBody>
+          <a:bodyPr wrap="square" anchor="t" lIns="0" rIns="0" tIns="0" bIns="0">
+            <a:spAutoFit/>
+          </a:bodyPr>
+          <a:lstStyle/>
+          <a:p>
+            <a:pPr algn="l">
+              <a:spcAft>
+                <a:spcPts val="720"/>
+              </a:spcAft>
+            </a:pPr>
+            <a:r>
+              <a:rPr sz="1600" b="0" i="0">
+                <a:solidFill>
+                  <a:srgbClr val="1A1A1A"/>
+                </a:solidFill>
+                <a:latin typeface="Calibri"/>
+              </a:rPr>
+              <a:t>10 species can't be separated by any barcode-only method.</a:t>
+            </a:r>
+          </a:p>
+        </p:txBody>
+      </p:sp>
+      <p:sp>
+        <p:nvSpPr>
+          <p:cNvPr id="16" name="Rounded Rectangle 15"/>
+          <p:cNvSpPr/>
+          <p:nvPr/>
+        </p:nvSpPr>
+        <p:spPr>
+          <a:xfrm>
+            <a:off x="6263640" y="3749039"/>
+            <a:ext cx="5349240" cy="1874519"/>
+          </a:xfrm>
+          <a:prstGeom prst="roundRect">
+            <a:avLst>
+              <a:gd name="adj" fmla="val 8000"/>
+            </a:avLst>
+          </a:prstGeom>
+          <a:solidFill>
+            <a:srgbClr val="E6F0EF"/>
+          </a:solidFill>
+          <a:ln>
+            <a:noFill/>
+          </a:ln>
+          <a:effectLst/>
+        </p:spPr>
+        <p:style>
+          <a:lnRef idx="1">
+            <a:schemeClr val="accent1"/>
+          </a:lnRef>
+          <a:fillRef idx="3">
+            <a:schemeClr val="accent1"/>
+          </a:fillRef>
+          <a:effectRef idx="2">
+            <a:schemeClr val="accent1"/>
+          </a:effectRef>
+          <a:fontRef idx="minor">
+            <a:schemeClr val="lt1"/>
+          </a:fontRef>
+        </p:style>
+        <p:txBody>
+          <a:bodyPr rtlCol="0" anchor="ctr"/>
+          <a:lstStyle/>
+          <a:p>
+            <a:pPr algn="ctr"/>
+          </a:p>
+        </p:txBody>
+      </p:sp>
+      <p:sp>
+        <p:nvSpPr>
+          <p:cNvPr id="17" name="Oval 16"/>
+          <p:cNvSpPr/>
+          <p:nvPr/>
+        </p:nvSpPr>
+        <p:spPr>
+          <a:xfrm>
+            <a:off x="6583679" y="4069079"/>
+            <a:ext cx="566928" cy="566928"/>
+          </a:xfrm>
+          <a:prstGeom prst="ellipse">
+            <a:avLst/>
+          </a:prstGeom>
+          <a:solidFill>
+            <a:srgbClr val="0F3B40"/>
+          </a:solidFill>
+          <a:ln>
+            <a:noFill/>
+          </a:ln>
+          <a:effectLst/>
+        </p:spPr>
+        <p:style>
+          <a:lnRef idx="1">
+            <a:schemeClr val="accent1"/>
+          </a:lnRef>
+          <a:fillRef idx="3">
+            <a:schemeClr val="accent1"/>
+          </a:fillRef>
+          <a:effectRef idx="2">
+            <a:schemeClr val="accent1"/>
+          </a:effectRef>
+          <a:fontRef idx="minor">
+            <a:schemeClr val="lt1"/>
+          </a:fontRef>
+        </p:style>
+        <p:txBody>
+          <a:bodyPr rtlCol="0" anchor="ctr" lIns="0" rIns="0" tIns="0" bIns="0"/>
+          <a:lstStyle/>
+          <a:p>
+            <a:pPr algn="ctr"/>
+            <a:r>
+              <a:rPr sz="1800" b="1">
+                <a:solidFill>
+                  <a:srgbClr val="FFFFFF"/>
+                </a:solidFill>
+                <a:latin typeface="Cambria"/>
+              </a:rPr>
+              <a:t>4</a:t>
+            </a:r>
+          </a:p>
+        </p:txBody>
+      </p:sp>
+      <p:sp>
+        <p:nvSpPr>
+          <p:cNvPr id="18" name="TextBox 17"/>
+          <p:cNvSpPr txBox="1"/>
+          <p:nvPr/>
+        </p:nvSpPr>
+        <p:spPr>
+          <a:xfrm>
+            <a:off x="7406640" y="4069079"/>
+            <a:ext cx="3931920" cy="457200"/>
+          </a:xfrm>
+          <a:prstGeom prst="rect">
+            <a:avLst/>
+          </a:prstGeom>
+          <a:noFill/>
+        </p:spPr>
+        <p:txBody>
+          <a:bodyPr wrap="square" anchor="t" lIns="0" rIns="0" tIns="0" bIns="0">
+            <a:spAutoFit/>
+          </a:bodyPr>
+          <a:lstStyle/>
+          <a:p>
+            <a:pPr algn="l">
+              <a:spcAft>
+                <a:spcPts val="900"/>
+              </a:spcAft>
+            </a:pPr>
+            <a:r>
+              <a:rPr sz="2000" b="1" i="0">
+                <a:solidFill>
+                  <a:srgbClr val="0F3B40"/>
+                </a:solidFill>
+                <a:latin typeface="Calibri"/>
+              </a:rPr>
+              <a:t>Different calibrations</a:t>
+            </a:r>
+          </a:p>
+        </p:txBody>
+      </p:sp>
+      <p:sp>
+        <p:nvSpPr>
+          <p:cNvPr id="19" name="TextBox 18"/>
+          <p:cNvSpPr txBox="1"/>
+          <p:nvPr/>
+        </p:nvSpPr>
+        <p:spPr>
+          <a:xfrm>
+            <a:off x="7406640" y="4617720"/>
+            <a:ext cx="3931920" cy="914400"/>
+          </a:xfrm>
+          <a:prstGeom prst="rect">
+            <a:avLst/>
+          </a:prstGeom>
+          <a:noFill/>
+        </p:spPr>
+        <p:txBody>
+          <a:bodyPr wrap="square" anchor="t" lIns="0" rIns="0" tIns="0" bIns="0">
+            <a:spAutoFit/>
+          </a:bodyPr>
+          <a:lstStyle/>
+          <a:p>
+            <a:pPr algn="l">
+              <a:spcAft>
+                <a:spcPts val="720"/>
+              </a:spcAft>
+            </a:pPr>
+            <a:r>
+              <a:rPr sz="1600" b="0" i="0">
+                <a:solidFill>
+                  <a:srgbClr val="1A1A1A"/>
+                </a:solidFill>
+                <a:latin typeface="Calibri"/>
+              </a:rPr>
+              <a:t>Tree cut-off calibrated inside the tree, ML by cross-validation; one tree for all queries.</a:t>
+            </a:r>
+          </a:p>
+        </p:txBody>
+      </p:sp>
+    </p:spTree>
+  </p:cSld>
+  <p:clrMapOvr>
+    <a:masterClrMapping/>
+  </p:clrMapOvr>
+</p:sld>
+</file>
+
+<file path=ppt/slides/slide14.xml><?xml version="1.0" encoding="utf-8"?>
 <p:sld xmlns:a="http://schemas.openxmlformats.org/drawingml/2006/main" xmlns:p="http://schemas.openxmlformats.org/presentationml/2006/main" xmlns:r="http://schemas.openxmlformats.org/officeDocument/2006/relationships">
   <p:cSld>
     <p:bg>
@@ -6427,7 +6820,7 @@
                 </a:solidFill>
                 <a:latin typeface="Calibri"/>
               </a:rPr>
-              <a:t>13</a:t>
+              <a:t>14</a:t>
             </a:r>
           </a:p>
         </p:txBody>
@@ -6479,8 +6872,8 @@
         </p:nvSpPr>
         <p:spPr>
           <a:xfrm>
-            <a:off x="822960" y="1600200"/>
-            <a:ext cx="10515600" cy="1828800"/>
+            <a:off x="822960" y="1554480"/>
+            <a:ext cx="10515600" cy="2194560"/>
           </a:xfrm>
           <a:prstGeom prst="rect">
             <a:avLst/>
@@ -6495,62 +6888,26 @@
           <a:p>
             <a:pPr algn="l">
               <a:spcAft>
-                <a:spcPts val="1260"/>
-              </a:spcAft>
-            </a:pPr>
-            <a:r>
-              <a:rPr sz="2800" b="0" i="0">
+                <a:spcPts val="1170"/>
+              </a:spcAft>
+            </a:pPr>
+            <a:r>
+              <a:rPr sz="2600" b="1" i="0">
                 <a:solidFill>
                   <a:srgbClr val="FFFFFF"/>
                 </a:solidFill>
                 <a:latin typeface="Cambria"/>
               </a:rPr>
-              <a:t>Machine learning matched the tree on known species </a:t>
-            </a:r>
-            <a:r>
-              <a:rPr sz="2800" b="1" i="0">
+              <a:t>The calibrated 'unknown' cut-off, not the method, makes identification safe. </a:t>
+            </a:r>
+            <a:r>
+              <a:rPr sz="2600" b="0" i="0">
                 <a:solidFill>
                   <a:srgbClr val="FFFFFF"/>
                 </a:solidFill>
                 <a:latin typeface="Cambria"/>
               </a:rPr>
-              <a:t>(93% vs 92%) </a:t>
-            </a:r>
-            <a:r>
-              <a:rPr sz="2800" b="0" i="0">
-                <a:solidFill>
-                  <a:srgbClr val="FFFFFF"/>
-                </a:solidFill>
-                <a:latin typeface="Cambria"/>
-              </a:rPr>
-              <a:t>but wrongly named unknown species over four times less often </a:t>
-            </a:r>
-            <a:r>
-              <a:rPr sz="2800" b="1" i="0">
-                <a:solidFill>
-                  <a:srgbClr val="FFFFFF"/>
-                </a:solidFill>
-                <a:latin typeface="Cambria"/>
-              </a:rPr>
-              <a:t>(14% vs 67%, 39 species) </a:t>
-            </a:r>
-            <a:r>
-              <a:rPr sz="2800" b="0" i="0">
-                <a:solidFill>
-                  <a:srgbClr val="FFFFFF"/>
-                </a:solidFill>
-                <a:latin typeface="Cambria"/>
-              </a:rPr>
-              <a:t>and was </a:t>
-            </a:r>
-            <a:r>
-              <a:rPr sz="2800" b="1" i="0">
-                <a:solidFill>
-                  <a:srgbClr val="FFFFFF"/>
-                </a:solidFill>
-                <a:latin typeface="Cambria"/>
-              </a:rPr>
-              <a:t>~264× faster.</a:t>
+              <a:t>Without one, the tree wrongly named 67% of missing species; with one, the tree and k-NN wrongly named 10% and 14% (39 species), and k-NN was ~264× faster.</a:t>
             </a:r>
           </a:p>
         </p:txBody>
@@ -6563,8 +6920,8 @@
         </p:nvSpPr>
         <p:spPr>
           <a:xfrm>
-            <a:off x="822960" y="3931920"/>
-            <a:ext cx="10515600" cy="1463040"/>
+            <a:off x="822960" y="4069080"/>
+            <a:ext cx="10515600" cy="1371600"/>
           </a:xfrm>
           <a:prstGeom prst="rect">
             <a:avLst/>
@@ -6589,7 +6946,7 @@
                 </a:solidFill>
                 <a:latin typeface="Calibri"/>
               </a:rPr>
-              <a:t>Use a distance-aware method with a calibrated 'unknown' threshold, not a species name read off a tree.</a:t>
+              <a:t>Whatever method you use, give it a calibrated 'unknown' cut-off; k-NN is the fast way.</a:t>
             </a:r>
           </a:p>
           <a:p>
@@ -8597,7 +8954,7 @@
                 </a:solidFill>
                 <a:latin typeface="Calibri"/>
               </a:rPr>
-              <a:t>Unknown? Only 'ambiguous' if that clade has several species</a:t>
+              <a:t>Unknown? Plain: only 'ambiguous'. + cut-off: if far from all references on the tree</a:t>
             </a:r>
           </a:p>
         </p:txBody>
@@ -9284,7 +9641,7 @@
                 </a:solidFill>
                 <a:latin typeface="Calibri"/>
               </a:rPr>
-              <a:t>k-NN and RF use k-mer frequencies (k = 4 and k = 6); 'unknown' thresholds are calibrated on training data only, accepting 95% of known species.</a:t>
+              <a:t>k-NN and RF use k-mers (k = 4, 6). Every 'unknown' cut-off, the tree's included, accepts 95% of known species (training data only).</a:t>
             </a:r>
           </a:p>
         </p:txBody>
@@ -10673,8 +11030,8 @@
         </p:blipFill>
         <p:spPr>
           <a:xfrm>
-            <a:off x="365760" y="1234440"/>
-            <a:ext cx="7641771" cy="5349240"/>
+            <a:off x="365760" y="1188720"/>
+            <a:ext cx="7315200" cy="5486400"/>
           </a:xfrm>
           <a:prstGeom prst="rect">
             <a:avLst/>
@@ -10689,7 +11046,7 @@
         </p:nvSpPr>
         <p:spPr>
           <a:xfrm>
-            <a:off x="8321040" y="1463040"/>
+            <a:off x="8321040" y="1371600"/>
             <a:ext cx="3474720" cy="868680"/>
           </a:xfrm>
           <a:prstGeom prst="rect">
@@ -10705,11 +11062,11 @@
           <a:p>
             <a:pPr algn="l">
               <a:spcAft>
-                <a:spcPts val="2250"/>
-              </a:spcAft>
-            </a:pPr>
-            <a:r>
-              <a:rPr sz="5000" b="1" i="0">
+                <a:spcPts val="2160"/>
+              </a:spcAft>
+            </a:pPr>
+            <a:r>
+              <a:rPr sz="4800" b="1" i="0">
                 <a:solidFill>
                   <a:srgbClr val="C03535"/>
                 </a:solidFill>
@@ -10728,7 +11085,7 @@
         </p:nvSpPr>
         <p:spPr>
           <a:xfrm>
-            <a:off x="8321040" y="2331720"/>
+            <a:off x="8321040" y="2240280"/>
             <a:ext cx="3474720" cy="731520"/>
           </a:xfrm>
           <a:prstGeom prst="rect">
@@ -10754,7 +11111,7 @@
                 </a:solidFill>
                 <a:latin typeface="Calibri"/>
               </a:rPr>
-              <a:t>NJ tree: unknown species
+              <a:t>plain NJ tree: unknown species
 given a wrong name</a:t>
             </a:r>
           </a:p>
@@ -10768,7 +11125,7 @@
         </p:nvSpPr>
         <p:spPr>
           <a:xfrm>
-            <a:off x="8321040" y="3246120"/>
+            <a:off x="8321040" y="3063240"/>
             <a:ext cx="3474720" cy="868680"/>
           </a:xfrm>
           <a:prstGeom prst="rect">
@@ -10784,11 +11141,11 @@
           <a:p>
             <a:pPr algn="l">
               <a:spcAft>
-                <a:spcPts val="2250"/>
-              </a:spcAft>
-            </a:pPr>
-            <a:r>
-              <a:rPr sz="5000" b="1" i="0">
+                <a:spcPts val="2160"/>
+              </a:spcAft>
+            </a:pPr>
+            <a:r>
+              <a:rPr sz="4800" b="1" i="0">
                 <a:solidFill>
                   <a:srgbClr val="0C8A0C"/>
                 </a:solidFill>
@@ -10807,7 +11164,7 @@
         </p:nvSpPr>
         <p:spPr>
           <a:xfrm>
-            <a:off x="8321040" y="4114800"/>
+            <a:off x="8321040" y="3931920"/>
             <a:ext cx="3474720" cy="731520"/>
           </a:xfrm>
           <a:prstGeom prst="rect">
@@ -10833,8 +11190,8 @@
                 </a:solidFill>
                 <a:latin typeface="Calibri"/>
               </a:rPr>
-              <a:t>k-NN with its threshold:
-all flagged 'unknown'</a:t>
+              <a:t>k-NN with its cut-off
+and NJ tree + cut-off</a:t>
             </a:r>
           </a:p>
         </p:txBody>
@@ -10847,7 +11204,7 @@
         </p:nvSpPr>
         <p:spPr>
           <a:xfrm>
-            <a:off x="8321040" y="5120640"/>
+            <a:off x="8321040" y="5029200"/>
             <a:ext cx="3474720" cy="548640"/>
           </a:xfrm>
           <a:prstGeom prst="rect">
@@ -10991,7 +11348,7 @@
         <p:spPr>
           <a:xfrm>
             <a:off x="548640" y="1417320"/>
-            <a:ext cx="5669280" cy="2240280"/>
+            <a:ext cx="6035040" cy="2240280"/>
           </a:xfrm>
           <a:prstGeom prst="roundRect">
             <a:avLst>
@@ -11036,8 +11393,8 @@
         </p:nvSpPr>
         <p:spPr>
           <a:xfrm>
-            <a:off x="868680" y="1600200"/>
-            <a:ext cx="5029200" cy="457200"/>
+            <a:off x="822960" y="1600200"/>
+            <a:ext cx="5486400" cy="457200"/>
           </a:xfrm>
           <a:prstGeom prst="rect">
             <a:avLst/>
@@ -11062,7 +11419,7 @@
                 </a:solidFill>
                 <a:latin typeface="Calibri"/>
               </a:rPr>
-              <a:t>All 39 species</a:t>
+              <a:t>All 39 species: wrongly named</a:t>
             </a:r>
           </a:p>
         </p:txBody>
@@ -11075,8 +11432,8 @@
         </p:nvSpPr>
         <p:spPr>
           <a:xfrm>
-            <a:off x="868680" y="2011680"/>
-            <a:ext cx="2377440" cy="868680"/>
+            <a:off x="822960" y="2057400"/>
+            <a:ext cx="1737360" cy="868680"/>
           </a:xfrm>
           <a:prstGeom prst="rect">
             <a:avLst/>
@@ -11091,11 +11448,11 @@
           <a:p>
             <a:pPr algn="l">
               <a:spcAft>
-                <a:spcPts val="2160"/>
-              </a:spcAft>
-            </a:pPr>
-            <a:r>
-              <a:rPr sz="4800" b="1" i="0">
+                <a:spcPts val="1800"/>
+              </a:spcAft>
+            </a:pPr>
+            <a:r>
+              <a:rPr sz="4000" b="1" i="0">
                 <a:solidFill>
                   <a:srgbClr val="C03535"/>
                 </a:solidFill>
@@ -11114,8 +11471,8 @@
         </p:nvSpPr>
         <p:spPr>
           <a:xfrm>
-            <a:off x="868680" y="2880360"/>
-            <a:ext cx="2377440" cy="731520"/>
+            <a:off x="822960" y="2926080"/>
+            <a:ext cx="1737360" cy="731520"/>
           </a:xfrm>
           <a:prstGeom prst="rect">
             <a:avLst/>
@@ -11140,7 +11497,7 @@
                 </a:solidFill>
                 <a:latin typeface="Calibri"/>
               </a:rPr>
-              <a:t>NJ tree wrongly named</a:t>
+              <a:t>plain NJ tree</a:t>
             </a:r>
           </a:p>
         </p:txBody>
@@ -11153,8 +11510,8 @@
         </p:nvSpPr>
         <p:spPr>
           <a:xfrm>
-            <a:off x="3429000" y="2011680"/>
-            <a:ext cx="2377440" cy="868680"/>
+            <a:off x="2743200" y="2057400"/>
+            <a:ext cx="1737360" cy="868680"/>
           </a:xfrm>
           <a:prstGeom prst="rect">
             <a:avLst/>
@@ -11169,17 +11526,17 @@
           <a:p>
             <a:pPr algn="l">
               <a:spcAft>
-                <a:spcPts val="2160"/>
-              </a:spcAft>
-            </a:pPr>
-            <a:r>
-              <a:rPr sz="4800" b="1" i="0">
+                <a:spcPts val="1800"/>
+              </a:spcAft>
+            </a:pPr>
+            <a:r>
+              <a:rPr sz="4000" b="1" i="0">
                 <a:solidFill>
                   <a:srgbClr val="0C8A0C"/>
                 </a:solidFill>
                 <a:latin typeface="Cambria"/>
               </a:rPr>
-              <a:t>14%</a:t>
+              <a:t>10%</a:t>
             </a:r>
           </a:p>
         </p:txBody>
@@ -11192,8 +11549,8 @@
         </p:nvSpPr>
         <p:spPr>
           <a:xfrm>
-            <a:off x="3429000" y="2880360"/>
-            <a:ext cx="2377440" cy="731520"/>
+            <a:off x="2743200" y="2926080"/>
+            <a:ext cx="1737360" cy="731520"/>
           </a:xfrm>
           <a:prstGeom prst="rect">
             <a:avLst/>
@@ -11218,21 +11575,99 @@
                 </a:solidFill>
                 <a:latin typeface="Calibri"/>
               </a:rPr>
-              <a:t>k-NN wrongly named</a:t>
-            </a:r>
-          </a:p>
-        </p:txBody>
-      </p:sp>
-      <p:sp>
-        <p:nvSpPr>
-          <p:cNvPr id="10" name="Rounded Rectangle 9"/>
+              <a:t>NJ + cut-off</a:t>
+            </a:r>
+          </a:p>
+        </p:txBody>
+      </p:sp>
+      <p:sp>
+        <p:nvSpPr>
+          <p:cNvPr id="10" name="TextBox 9"/>
+          <p:cNvSpPr txBox="1"/>
+          <p:nvPr/>
+        </p:nvSpPr>
+        <p:spPr>
+          <a:xfrm>
+            <a:off x="4663440" y="2057400"/>
+            <a:ext cx="1737360" cy="868680"/>
+          </a:xfrm>
+          <a:prstGeom prst="rect">
+            <a:avLst/>
+          </a:prstGeom>
+          <a:noFill/>
+        </p:spPr>
+        <p:txBody>
+          <a:bodyPr wrap="square" anchor="t" lIns="0" rIns="0" tIns="0" bIns="0">
+            <a:spAutoFit/>
+          </a:bodyPr>
+          <a:lstStyle/>
+          <a:p>
+            <a:pPr algn="l">
+              <a:spcAft>
+                <a:spcPts val="1800"/>
+              </a:spcAft>
+            </a:pPr>
+            <a:r>
+              <a:rPr sz="4000" b="1" i="0">
+                <a:solidFill>
+                  <a:srgbClr val="0C8A0C"/>
+                </a:solidFill>
+                <a:latin typeface="Cambria"/>
+              </a:rPr>
+              <a:t>14%</a:t>
+            </a:r>
+          </a:p>
+        </p:txBody>
+      </p:sp>
+      <p:sp>
+        <p:nvSpPr>
+          <p:cNvPr id="11" name="TextBox 10"/>
+          <p:cNvSpPr txBox="1"/>
+          <p:nvPr/>
+        </p:nvSpPr>
+        <p:spPr>
+          <a:xfrm>
+            <a:off x="4663440" y="2926080"/>
+            <a:ext cx="1737360" cy="731520"/>
+          </a:xfrm>
+          <a:prstGeom prst="rect">
+            <a:avLst/>
+          </a:prstGeom>
+          <a:noFill/>
+        </p:spPr>
+        <p:txBody>
+          <a:bodyPr wrap="square" anchor="t" lIns="0" rIns="0" tIns="0" bIns="0">
+            <a:spAutoFit/>
+          </a:bodyPr>
+          <a:lstStyle/>
+          <a:p>
+            <a:pPr algn="l">
+              <a:spcAft>
+                <a:spcPts val="630"/>
+              </a:spcAft>
+            </a:pPr>
+            <a:r>
+              <a:rPr sz="1400" b="0" i="0">
+                <a:solidFill>
+                  <a:srgbClr val="5A5A55"/>
+                </a:solidFill>
+                <a:latin typeface="Calibri"/>
+              </a:rPr>
+              <a:t>k-NN</a:t>
+            </a:r>
+          </a:p>
+        </p:txBody>
+      </p:sp>
+      <p:sp>
+        <p:nvSpPr>
+          <p:cNvPr id="12" name="Rounded Rectangle 11"/>
           <p:cNvSpPr/>
           <p:nvPr/>
         </p:nvSpPr>
         <p:spPr>
           <a:xfrm>
             <a:off x="548640" y="3886200"/>
-            <a:ext cx="5669280" cy="2240280"/>
+            <a:ext cx="6035040" cy="2240280"/>
           </a:xfrm>
           <a:prstGeom prst="roundRect">
             <a:avLst>
@@ -11271,14 +11706,14 @@
       </p:sp>
       <p:sp>
         <p:nvSpPr>
-          <p:cNvPr id="11" name="TextBox 10"/>
+          <p:cNvPr id="13" name="TextBox 12"/>
           <p:cNvSpPr txBox="1"/>
           <p:nvPr/>
         </p:nvSpPr>
         <p:spPr>
           <a:xfrm>
-            <a:off x="868680" y="4069080"/>
-            <a:ext cx="5120640" cy="457200"/>
+            <a:off x="822960" y="4069080"/>
+            <a:ext cx="5486400" cy="457200"/>
           </a:xfrm>
           <a:prstGeom prst="rect">
             <a:avLst/>
@@ -11310,14 +11745,14 @@
       </p:sp>
       <p:sp>
         <p:nvSpPr>
-          <p:cNvPr id="12" name="TextBox 11"/>
+          <p:cNvPr id="14" name="TextBox 13"/>
           <p:cNvSpPr txBox="1"/>
           <p:nvPr/>
         </p:nvSpPr>
         <p:spPr>
           <a:xfrm>
-            <a:off x="868680" y="4480560"/>
-            <a:ext cx="2377440" cy="868680"/>
+            <a:off x="822960" y="4526280"/>
+            <a:ext cx="1737360" cy="868680"/>
           </a:xfrm>
           <a:prstGeom prst="rect">
             <a:avLst/>
@@ -11332,11 +11767,11 @@
           <a:p>
             <a:pPr algn="l">
               <a:spcAft>
-                <a:spcPts val="2160"/>
-              </a:spcAft>
-            </a:pPr>
-            <a:r>
-              <a:rPr sz="4800" b="1" i="0">
+                <a:spcPts val="1800"/>
+              </a:spcAft>
+            </a:pPr>
+            <a:r>
+              <a:rPr sz="4000" b="1" i="0">
                 <a:solidFill>
                   <a:srgbClr val="C03535"/>
                 </a:solidFill>
@@ -11349,14 +11784,14 @@
       </p:sp>
       <p:sp>
         <p:nvSpPr>
-          <p:cNvPr id="13" name="TextBox 12"/>
+          <p:cNvPr id="15" name="TextBox 14"/>
           <p:cNvSpPr txBox="1"/>
           <p:nvPr/>
         </p:nvSpPr>
         <p:spPr>
           <a:xfrm>
-            <a:off x="868680" y="5349240"/>
-            <a:ext cx="2377440" cy="731520"/>
+            <a:off x="822960" y="5394960"/>
+            <a:ext cx="1737360" cy="731520"/>
           </a:xfrm>
           <a:prstGeom prst="rect">
             <a:avLst/>
@@ -11381,21 +11816,21 @@
                 </a:solidFill>
                 <a:latin typeface="Calibri"/>
               </a:rPr>
-              <a:t>NJ tree wrongly named</a:t>
-            </a:r>
-          </a:p>
-        </p:txBody>
-      </p:sp>
-      <p:sp>
-        <p:nvSpPr>
-          <p:cNvPr id="14" name="TextBox 13"/>
+              <a:t>plain NJ tree</a:t>
+            </a:r>
+          </a:p>
+        </p:txBody>
+      </p:sp>
+      <p:sp>
+        <p:nvSpPr>
+          <p:cNvPr id="16" name="TextBox 15"/>
           <p:cNvSpPr txBox="1"/>
           <p:nvPr/>
         </p:nvSpPr>
         <p:spPr>
           <a:xfrm>
-            <a:off x="3429000" y="4480560"/>
-            <a:ext cx="2377440" cy="868680"/>
+            <a:off x="2743200" y="4526280"/>
+            <a:ext cx="1737360" cy="868680"/>
           </a:xfrm>
           <a:prstGeom prst="rect">
             <a:avLst/>
@@ -11410,11 +11845,11 @@
           <a:p>
             <a:pPr algn="l">
               <a:spcAft>
-                <a:spcPts val="2160"/>
-              </a:spcAft>
-            </a:pPr>
-            <a:r>
-              <a:rPr sz="4800" b="1" i="0">
+                <a:spcPts val="1800"/>
+              </a:spcAft>
+            </a:pPr>
+            <a:r>
+              <a:rPr sz="4000" b="1" i="0">
                 <a:solidFill>
                   <a:srgbClr val="0C8A0C"/>
                 </a:solidFill>
@@ -11427,14 +11862,14 @@
       </p:sp>
       <p:sp>
         <p:nvSpPr>
-          <p:cNvPr id="15" name="TextBox 14"/>
+          <p:cNvPr id="17" name="TextBox 16"/>
           <p:cNvSpPr txBox="1"/>
           <p:nvPr/>
         </p:nvSpPr>
         <p:spPr>
           <a:xfrm>
-            <a:off x="3429000" y="5349240"/>
-            <a:ext cx="2377440" cy="731520"/>
+            <a:off x="2743200" y="5394960"/>
+            <a:ext cx="1737360" cy="731520"/>
           </a:xfrm>
           <a:prstGeom prst="rect">
             <a:avLst/>
@@ -11459,15 +11894,92 @@
                 </a:solidFill>
                 <a:latin typeface="Calibri"/>
               </a:rPr>
-              <a:t>k-NN wrongly named
-(correct genus 99%)</a:t>
+              <a:t>NJ + cut-off</a:t>
+            </a:r>
+          </a:p>
+        </p:txBody>
+      </p:sp>
+      <p:sp>
+        <p:nvSpPr>
+          <p:cNvPr id="18" name="TextBox 17"/>
+          <p:cNvSpPr txBox="1"/>
+          <p:nvPr/>
+        </p:nvSpPr>
+        <p:spPr>
+          <a:xfrm>
+            <a:off x="4663440" y="4526280"/>
+            <a:ext cx="1737360" cy="868680"/>
+          </a:xfrm>
+          <a:prstGeom prst="rect">
+            <a:avLst/>
+          </a:prstGeom>
+          <a:noFill/>
+        </p:spPr>
+        <p:txBody>
+          <a:bodyPr wrap="square" anchor="t" lIns="0" rIns="0" tIns="0" bIns="0">
+            <a:spAutoFit/>
+          </a:bodyPr>
+          <a:lstStyle/>
+          <a:p>
+            <a:pPr algn="l">
+              <a:spcAft>
+                <a:spcPts val="1800"/>
+              </a:spcAft>
+            </a:pPr>
+            <a:r>
+              <a:rPr sz="4000" b="1" i="0">
+                <a:solidFill>
+                  <a:srgbClr val="0C8A0C"/>
+                </a:solidFill>
+                <a:latin typeface="Cambria"/>
+              </a:rPr>
+              <a:t>0%</a:t>
+            </a:r>
+          </a:p>
+        </p:txBody>
+      </p:sp>
+      <p:sp>
+        <p:nvSpPr>
+          <p:cNvPr id="19" name="TextBox 18"/>
+          <p:cNvSpPr txBox="1"/>
+          <p:nvPr/>
+        </p:nvSpPr>
+        <p:spPr>
+          <a:xfrm>
+            <a:off x="4663440" y="5394960"/>
+            <a:ext cx="1737360" cy="731520"/>
+          </a:xfrm>
+          <a:prstGeom prst="rect">
+            <a:avLst/>
+          </a:prstGeom>
+          <a:noFill/>
+        </p:spPr>
+        <p:txBody>
+          <a:bodyPr wrap="square" anchor="t" lIns="0" rIns="0" tIns="0" bIns="0">
+            <a:spAutoFit/>
+          </a:bodyPr>
+          <a:lstStyle/>
+          <a:p>
+            <a:pPr algn="l">
+              <a:spcAft>
+                <a:spcPts val="630"/>
+              </a:spcAft>
+            </a:pPr>
+            <a:r>
+              <a:rPr sz="1400" b="0" i="0">
+                <a:solidFill>
+                  <a:srgbClr val="5A5A55"/>
+                </a:solidFill>
+                <a:latin typeface="Calibri"/>
+              </a:rPr>
+              <a:t>k-NN</a:t>
             </a:r>
           </a:p>
         </p:txBody>
       </p:sp>
       <p:pic>
         <p:nvPicPr>
-          <p:cNvPr id="16" name="Picture 15" descr="loso_per_species.png"/>
+          <p:cNvPr id="20" name="Picture 19" descr="loso_per_species.png"/>
           <p:cNvPicPr>
             <a:picLocks noChangeAspect="1"/>
           </p:cNvPicPr>

</xml_diff>